<commit_message>
fix: Replace Linux-only fonts with universal Arial Black + Calibri
Liberation Sans and Carlito are Linux-only fonts that showed as missing
on macOS. Replaced with Arial Black (headers) and Calibri (body) which
are pre-installed on both Mac and Windows.

Co-Authored-By: Claude Opus 4.6 <noreply@anthropic.com>
</commit_message>
<xml_diff>
--- a/Top_Performer_Executive_Pitch.pptx
+++ b/Top_Performer_Executive_Pitch.pptx
@@ -2276,9 +2276,9 @@
                 <a:solidFill>
                   <a:srgbClr val="FFFFFF"/>
                 </a:solidFill>
-                <a:latin typeface="Liberation Sans" pitchFamily="34" charset="0"/>
-                <a:ea typeface="Liberation Sans" pitchFamily="34" charset="-122"/>
-                <a:cs typeface="Liberation Sans" pitchFamily="34" charset="-120"/>
+                <a:latin typeface="Arial Black" pitchFamily="34" charset="0"/>
+                <a:ea typeface="Arial Black" pitchFamily="34" charset="-122"/>
+                <a:cs typeface="Arial Black" pitchFamily="34" charset="-120"/>
               </a:rPr>
               <a:t>TOP PERFORMER</a:t>
             </a:r>
@@ -2337,9 +2337,9 @@
                 <a:solidFill>
                   <a:srgbClr val="0A0A0A"/>
                 </a:solidFill>
-                <a:latin typeface="Liberation Sans" pitchFamily="34" charset="0"/>
-                <a:ea typeface="Liberation Sans" pitchFamily="34" charset="-122"/>
-                <a:cs typeface="Liberation Sans" pitchFamily="34" charset="-120"/>
+                <a:latin typeface="Arial Black" pitchFamily="34" charset="0"/>
+                <a:ea typeface="Arial Black" pitchFamily="34" charset="-122"/>
+                <a:cs typeface="Arial Black" pitchFamily="34" charset="-120"/>
               </a:rPr>
               <a:t>TP 1%</a:t>
             </a:r>
@@ -2376,9 +2376,9 @@
                 <a:solidFill>
                   <a:srgbClr val="D4A017"/>
                 </a:solidFill>
-                <a:latin typeface="Carlito" pitchFamily="34" charset="0"/>
-                <a:ea typeface="Carlito" pitchFamily="34" charset="-122"/>
-                <a:cs typeface="Carlito" pitchFamily="34" charset="-120"/>
+                <a:latin typeface="Calibri" pitchFamily="34" charset="0"/>
+                <a:ea typeface="Calibri" pitchFamily="34" charset="-122"/>
+                <a:cs typeface="Calibri" pitchFamily="34" charset="-120"/>
               </a:rPr>
               <a:t>The Mental Coach You Always Needed</a:t>
             </a:r>
@@ -2415,9 +2415,9 @@
                 <a:solidFill>
                   <a:srgbClr val="00D4FF"/>
                 </a:solidFill>
-                <a:latin typeface="Carlito" pitchFamily="34" charset="0"/>
-                <a:ea typeface="Carlito" pitchFamily="34" charset="-122"/>
-                <a:cs typeface="Carlito" pitchFamily="34" charset="-120"/>
+                <a:latin typeface="Calibri" pitchFamily="34" charset="0"/>
+                <a:ea typeface="Calibri" pitchFamily="34" charset="-122"/>
+                <a:cs typeface="Calibri" pitchFamily="34" charset="-120"/>
               </a:rPr>
               <a:t>Artificial Intelligence</a:t>
             </a:r>
@@ -2429,9 +2429,9 @@
                 <a:solidFill>
                   <a:srgbClr val="888888"/>
                 </a:solidFill>
-                <a:latin typeface="Carlito" pitchFamily="34" charset="0"/>
-                <a:ea typeface="Carlito" pitchFamily="34" charset="-122"/>
-                <a:cs typeface="Carlito" pitchFamily="34" charset="-120"/>
+                <a:latin typeface="Calibri" pitchFamily="34" charset="0"/>
+                <a:ea typeface="Calibri" pitchFamily="34" charset="-122"/>
+                <a:cs typeface="Calibri" pitchFamily="34" charset="-120"/>
               </a:rPr>
               <a:t>  +  </a:t>
             </a:r>
@@ -2443,9 +2443,9 @@
                 <a:solidFill>
                   <a:srgbClr val="E94560"/>
                 </a:solidFill>
-                <a:latin typeface="Carlito" pitchFamily="34" charset="0"/>
-                <a:ea typeface="Carlito" pitchFamily="34" charset="-122"/>
-                <a:cs typeface="Carlito" pitchFamily="34" charset="-120"/>
+                <a:latin typeface="Calibri" pitchFamily="34" charset="0"/>
+                <a:ea typeface="Calibri" pitchFamily="34" charset="-122"/>
+                <a:cs typeface="Calibri" pitchFamily="34" charset="-120"/>
               </a:rPr>
               <a:t>Emotional Intelligence</a:t>
             </a:r>
@@ -2554,9 +2554,9 @@
                 <a:solidFill>
                   <a:srgbClr val="E94560"/>
                 </a:solidFill>
-                <a:latin typeface="Carlito" pitchFamily="34" charset="0"/>
-                <a:ea typeface="Carlito" pitchFamily="34" charset="-122"/>
-                <a:cs typeface="Carlito" pitchFamily="34" charset="-120"/>
+                <a:latin typeface="Calibri" pitchFamily="34" charset="0"/>
+                <a:ea typeface="Calibri" pitchFamily="34" charset="-122"/>
+                <a:cs typeface="Calibri" pitchFamily="34" charset="-120"/>
               </a:rPr>
               <a:t>GO-TO-MARKET</a:t>
             </a:r>
@@ -2593,9 +2593,9 @@
                 <a:solidFill>
                   <a:srgbClr val="FFFFFF"/>
                 </a:solidFill>
-                <a:latin typeface="Liberation Sans" pitchFamily="34" charset="0"/>
-                <a:ea typeface="Liberation Sans" pitchFamily="34" charset="-122"/>
-                <a:cs typeface="Liberation Sans" pitchFamily="34" charset="-120"/>
+                <a:latin typeface="Arial Black" pitchFamily="34" charset="0"/>
+                <a:ea typeface="Arial Black" pitchFamily="34" charset="-122"/>
+                <a:cs typeface="Arial Black" pitchFamily="34" charset="-120"/>
               </a:rPr>
               <a:t>Marketing Strategies That Print Money</a:t>
             </a:r>
@@ -2679,9 +2679,9 @@
                 <a:solidFill>
                   <a:srgbClr val="E94560"/>
                 </a:solidFill>
-                <a:latin typeface="Carlito" pitchFamily="34" charset="0"/>
-                <a:ea typeface="Carlito" pitchFamily="34" charset="-122"/>
-                <a:cs typeface="Carlito" pitchFamily="34" charset="-120"/>
+                <a:latin typeface="Calibri" pitchFamily="34" charset="0"/>
+                <a:ea typeface="Calibri" pitchFamily="34" charset="-122"/>
+                <a:cs typeface="Calibri" pitchFamily="34" charset="-120"/>
               </a:rPr>
               <a:t>"Are You In The 1%?" Campaign</a:t>
             </a:r>
@@ -2718,9 +2718,9 @@
                 <a:solidFill>
                   <a:srgbClr val="888888"/>
                 </a:solidFill>
-                <a:latin typeface="Carlito" pitchFamily="34" charset="0"/>
-                <a:ea typeface="Carlito" pitchFamily="34" charset="-122"/>
-                <a:cs typeface="Carlito" pitchFamily="34" charset="-120"/>
+                <a:latin typeface="Calibri" pitchFamily="34" charset="0"/>
+                <a:ea typeface="Calibri" pitchFamily="34" charset="-122"/>
+                <a:cs typeface="Calibri" pitchFamily="34" charset="-120"/>
               </a:rPr>
               <a:t>Social media quiz funnel. Users take a 60-second "mental performance" assessment. Results show their score and invite them to join the TP 1%. Viral shareability built in.</a:t>
             </a:r>
@@ -2804,9 +2804,9 @@
                 <a:solidFill>
                   <a:srgbClr val="00D4FF"/>
                 </a:solidFill>
-                <a:latin typeface="Carlito" pitchFamily="34" charset="0"/>
-                <a:ea typeface="Carlito" pitchFamily="34" charset="-122"/>
-                <a:cs typeface="Carlito" pitchFamily="34" charset="-120"/>
+                <a:latin typeface="Calibri" pitchFamily="34" charset="0"/>
+                <a:ea typeface="Calibri" pitchFamily="34" charset="-122"/>
+                <a:cs typeface="Calibri" pitchFamily="34" charset="-120"/>
               </a:rPr>
               <a:t>Influencer Athlete Partnerships</a:t>
             </a:r>
@@ -2843,9 +2843,9 @@
                 <a:solidFill>
                   <a:srgbClr val="888888"/>
                 </a:solidFill>
-                <a:latin typeface="Carlito" pitchFamily="34" charset="0"/>
-                <a:ea typeface="Carlito" pitchFamily="34" charset="-122"/>
-                <a:cs typeface="Carlito" pitchFamily="34" charset="-120"/>
+                <a:latin typeface="Calibri" pitchFamily="34" charset="0"/>
+                <a:ea typeface="Calibri" pitchFamily="34" charset="-122"/>
+                <a:cs typeface="Calibri" pitchFamily="34" charset="-120"/>
               </a:rPr>
               <a:t>Partner with fitness influencers, MMA fighters, entrepreneurs. "This is my secret weapon." Authenticity sells. Target micro-influencers (10K-100K) for better ROI.</a:t>
             </a:r>
@@ -2929,9 +2929,9 @@
                 <a:solidFill>
                   <a:srgbClr val="00C853"/>
                 </a:solidFill>
-                <a:latin typeface="Carlito" pitchFamily="34" charset="0"/>
-                <a:ea typeface="Carlito" pitchFamily="34" charset="-122"/>
-                <a:cs typeface="Carlito" pitchFamily="34" charset="-120"/>
+                <a:latin typeface="Calibri" pitchFamily="34" charset="0"/>
+                <a:ea typeface="Calibri" pitchFamily="34" charset="-122"/>
+                <a:cs typeface="Calibri" pitchFamily="34" charset="-120"/>
               </a:rPr>
               <a:t>Corporate Wellness Packages</a:t>
             </a:r>
@@ -2968,9 +2968,9 @@
                 <a:solidFill>
                   <a:srgbClr val="888888"/>
                 </a:solidFill>
-                <a:latin typeface="Carlito" pitchFamily="34" charset="0"/>
-                <a:ea typeface="Carlito" pitchFamily="34" charset="-122"/>
-                <a:cs typeface="Carlito" pitchFamily="34" charset="-120"/>
+                <a:latin typeface="Calibri" pitchFamily="34" charset="0"/>
+                <a:ea typeface="Calibri" pitchFamily="34" charset="-122"/>
+                <a:cs typeface="Calibri" pitchFamily="34" charset="-120"/>
               </a:rPr>
               <a:t>Pitch to HR departments: "Reduce burnout, increase productivity." Offer team dashboards and bulk pricing. $5/user/mo at scale = massive B2B revenue.</a:t>
             </a:r>
@@ -3054,9 +3054,9 @@
                 <a:solidFill>
                   <a:srgbClr val="FFD700"/>
                 </a:solidFill>
-                <a:latin typeface="Carlito" pitchFamily="34" charset="0"/>
-                <a:ea typeface="Carlito" pitchFamily="34" charset="-122"/>
-                <a:cs typeface="Carlito" pitchFamily="34" charset="-120"/>
+                <a:latin typeface="Calibri" pitchFamily="34" charset="0"/>
+                <a:ea typeface="Calibri" pitchFamily="34" charset="-122"/>
+                <a:cs typeface="Calibri" pitchFamily="34" charset="-120"/>
               </a:rPr>
               <a:t>TikTok/Reels Content Engine</a:t>
             </a:r>
@@ -3093,9 +3093,9 @@
                 <a:solidFill>
                   <a:srgbClr val="888888"/>
                 </a:solidFill>
-                <a:latin typeface="Carlito" pitchFamily="34" charset="0"/>
-                <a:ea typeface="Carlito" pitchFamily="34" charset="-122"/>
-                <a:cs typeface="Carlito" pitchFamily="34" charset="-120"/>
+                <a:latin typeface="Calibri" pitchFamily="34" charset="0"/>
+                <a:ea typeface="Calibri" pitchFamily="34" charset="-122"/>
+                <a:cs typeface="Calibri" pitchFamily="34" charset="-120"/>
               </a:rPr>
               <a:t>Daily 30-second "mental performance tips" from the app. Quick wins, motivation, transformation stories. Hook: "What the top 1% do every morning that you don't."</a:t>
             </a:r>
@@ -3179,9 +3179,9 @@
                 <a:solidFill>
                   <a:srgbClr val="7C3AED"/>
                 </a:solidFill>
-                <a:latin typeface="Carlito" pitchFamily="34" charset="0"/>
-                <a:ea typeface="Carlito" pitchFamily="34" charset="-122"/>
-                <a:cs typeface="Carlito" pitchFamily="34" charset="-120"/>
+                <a:latin typeface="Calibri" pitchFamily="34" charset="0"/>
+                <a:ea typeface="Calibri" pitchFamily="34" charset="-122"/>
+                <a:cs typeface="Calibri" pitchFamily="34" charset="-120"/>
               </a:rPr>
               <a:t>Referral Competitions</a:t>
             </a:r>
@@ -3218,9 +3218,9 @@
                 <a:solidFill>
                   <a:srgbClr val="888888"/>
                 </a:solidFill>
-                <a:latin typeface="Carlito" pitchFamily="34" charset="0"/>
-                <a:ea typeface="Carlito" pitchFamily="34" charset="-122"/>
-                <a:cs typeface="Carlito" pitchFamily="34" charset="-120"/>
+                <a:latin typeface="Calibri" pitchFamily="34" charset="0"/>
+                <a:ea typeface="Calibri" pitchFamily="34" charset="-122"/>
+                <a:cs typeface="Calibri" pitchFamily="34" charset="-120"/>
               </a:rPr>
               <a:t>Monthly referral leaderboard with prizes. Top referrers get free lifetime access, merch, or cash rewards. Creates army of brand ambassadors.</a:t>
             </a:r>
@@ -3304,9 +3304,9 @@
                 <a:solidFill>
                   <a:srgbClr val="E94560"/>
                 </a:solidFill>
-                <a:latin typeface="Carlito" pitchFamily="34" charset="0"/>
-                <a:ea typeface="Carlito" pitchFamily="34" charset="-122"/>
-                <a:cs typeface="Carlito" pitchFamily="34" charset="-120"/>
+                <a:latin typeface="Calibri" pitchFamily="34" charset="0"/>
+                <a:ea typeface="Calibri" pitchFamily="34" charset="-122"/>
+                <a:cs typeface="Calibri" pitchFamily="34" charset="-120"/>
               </a:rPr>
               <a:t>Launch Day Scarcity</a:t>
             </a:r>
@@ -3343,9 +3343,9 @@
                 <a:solidFill>
                   <a:srgbClr val="888888"/>
                 </a:solidFill>
-                <a:latin typeface="Carlito" pitchFamily="34" charset="0"/>
-                <a:ea typeface="Carlito" pitchFamily="34" charset="-122"/>
-                <a:cs typeface="Carlito" pitchFamily="34" charset="-120"/>
+                <a:latin typeface="Calibri" pitchFamily="34" charset="0"/>
+                <a:ea typeface="Calibri" pitchFamily="34" charset="-122"/>
+                <a:cs typeface="Calibri" pitchFamily="34" charset="-120"/>
               </a:rPr>
               <a:t>"First 1,000 users get Founding Member status + lifetime 50% discount." Create urgency. Limited badges. Exclusive community access. FOMO drives downloads.</a:t>
             </a:r>
@@ -3434,9 +3434,9 @@
                 <a:solidFill>
                   <a:srgbClr val="00D4FF"/>
                 </a:solidFill>
-                <a:latin typeface="Carlito" pitchFamily="34" charset="0"/>
-                <a:ea typeface="Carlito" pitchFamily="34" charset="-122"/>
-                <a:cs typeface="Carlito" pitchFamily="34" charset="-120"/>
+                <a:latin typeface="Calibri" pitchFamily="34" charset="0"/>
+                <a:ea typeface="Calibri" pitchFamily="34" charset="-122"/>
+                <a:cs typeface="Calibri" pitchFamily="34" charset="-120"/>
               </a:rPr>
               <a:t>LAUNCH ROADMAP</a:t>
             </a:r>
@@ -3473,9 +3473,9 @@
                 <a:solidFill>
                   <a:srgbClr val="FFFFFF"/>
                 </a:solidFill>
-                <a:latin typeface="Liberation Sans" pitchFamily="34" charset="0"/>
-                <a:ea typeface="Liberation Sans" pitchFamily="34" charset="-122"/>
-                <a:cs typeface="Liberation Sans" pitchFamily="34" charset="-120"/>
+                <a:latin typeface="Arial Black" pitchFamily="34" charset="0"/>
+                <a:ea typeface="Arial Black" pitchFamily="34" charset="-122"/>
+                <a:cs typeface="Arial Black" pitchFamily="34" charset="-120"/>
               </a:rPr>
               <a:t>From Here to Market Domination</a:t>
             </a:r>
@@ -3555,9 +3555,9 @@
                 <a:solidFill>
                   <a:srgbClr val="00C853"/>
                 </a:solidFill>
-                <a:latin typeface="Carlito" pitchFamily="34" charset="0"/>
-                <a:ea typeface="Carlito" pitchFamily="34" charset="-122"/>
-                <a:cs typeface="Carlito" pitchFamily="34" charset="-120"/>
+                <a:latin typeface="Calibri" pitchFamily="34" charset="0"/>
+                <a:ea typeface="Calibri" pitchFamily="34" charset="-122"/>
+                <a:cs typeface="Calibri" pitchFamily="34" charset="-120"/>
               </a:rPr>
               <a:t>NOW</a:t>
             </a:r>
@@ -3645,9 +3645,9 @@
                 <a:solidFill>
                   <a:srgbClr val="FFFFFF"/>
                 </a:solidFill>
-                <a:latin typeface="Carlito" pitchFamily="34" charset="0"/>
-                <a:ea typeface="Carlito" pitchFamily="34" charset="-122"/>
-                <a:cs typeface="Carlito" pitchFamily="34" charset="-120"/>
+                <a:latin typeface="Calibri" pitchFamily="34" charset="0"/>
+                <a:ea typeface="Calibri" pitchFamily="34" charset="-122"/>
+                <a:cs typeface="Calibri" pitchFamily="34" charset="-120"/>
               </a:rPr>
               <a:t>App Store Submission</a:t>
             </a:r>
@@ -3684,9 +3684,9 @@
                 <a:solidFill>
                   <a:srgbClr val="888888"/>
                 </a:solidFill>
-                <a:latin typeface="Carlito" pitchFamily="34" charset="0"/>
-                <a:ea typeface="Carlito" pitchFamily="34" charset="-122"/>
-                <a:cs typeface="Carlito" pitchFamily="34" charset="-120"/>
+                <a:latin typeface="Calibri" pitchFamily="34" charset="0"/>
+                <a:ea typeface="Calibri" pitchFamily="34" charset="-122"/>
+                <a:cs typeface="Calibri" pitchFamily="34" charset="-120"/>
               </a:rPr>
               <a:t>Apple Developer setup, TestFlight beta,</a:t>
             </a:r>
@@ -3701,9 +3701,9 @@
                 <a:solidFill>
                   <a:srgbClr val="888888"/>
                 </a:solidFill>
-                <a:latin typeface="Carlito" pitchFamily="34" charset="0"/>
-                <a:ea typeface="Carlito" pitchFamily="34" charset="-122"/>
-                <a:cs typeface="Carlito" pitchFamily="34" charset="-120"/>
+                <a:latin typeface="Calibri" pitchFamily="34" charset="0"/>
+                <a:ea typeface="Calibri" pitchFamily="34" charset="-122"/>
+                <a:cs typeface="Calibri" pitchFamily="34" charset="-120"/>
               </a:rPr>
               <a:t>App Store metadata, screenshots</a:t>
             </a:r>
@@ -3760,9 +3760,9 @@
                 <a:solidFill>
                   <a:srgbClr val="00D4FF"/>
                 </a:solidFill>
-                <a:latin typeface="Carlito" pitchFamily="34" charset="0"/>
-                <a:ea typeface="Carlito" pitchFamily="34" charset="-122"/>
-                <a:cs typeface="Carlito" pitchFamily="34" charset="-120"/>
+                <a:latin typeface="Calibri" pitchFamily="34" charset="0"/>
+                <a:ea typeface="Calibri" pitchFamily="34" charset="-122"/>
+                <a:cs typeface="Calibri" pitchFamily="34" charset="-120"/>
               </a:rPr>
               <a:t>WEEK 2-4</a:t>
             </a:r>
@@ -3850,9 +3850,9 @@
                 <a:solidFill>
                   <a:srgbClr val="FFFFFF"/>
                 </a:solidFill>
-                <a:latin typeface="Carlito" pitchFamily="34" charset="0"/>
-                <a:ea typeface="Carlito" pitchFamily="34" charset="-122"/>
-                <a:cs typeface="Carlito" pitchFamily="34" charset="-120"/>
+                <a:latin typeface="Calibri" pitchFamily="34" charset="0"/>
+                <a:ea typeface="Calibri" pitchFamily="34" charset="-122"/>
+                <a:cs typeface="Calibri" pitchFamily="34" charset="-120"/>
               </a:rPr>
               <a:t>Beta Launch</a:t>
             </a:r>
@@ -3889,9 +3889,9 @@
                 <a:solidFill>
                   <a:srgbClr val="888888"/>
                 </a:solidFill>
-                <a:latin typeface="Carlito" pitchFamily="34" charset="0"/>
-                <a:ea typeface="Carlito" pitchFamily="34" charset="-122"/>
-                <a:cs typeface="Carlito" pitchFamily="34" charset="-120"/>
+                <a:latin typeface="Calibri" pitchFamily="34" charset="0"/>
+                <a:ea typeface="Calibri" pitchFamily="34" charset="-122"/>
+                <a:cs typeface="Calibri" pitchFamily="34" charset="-120"/>
               </a:rPr>
               <a:t>100 beta testers, gather feedback,</a:t>
             </a:r>
@@ -3906,9 +3906,9 @@
                 <a:solidFill>
                   <a:srgbClr val="888888"/>
                 </a:solidFill>
-                <a:latin typeface="Carlito" pitchFamily="34" charset="0"/>
-                <a:ea typeface="Carlito" pitchFamily="34" charset="-122"/>
-                <a:cs typeface="Carlito" pitchFamily="34" charset="-120"/>
+                <a:latin typeface="Calibri" pitchFamily="34" charset="0"/>
+                <a:ea typeface="Calibri" pitchFamily="34" charset="-122"/>
+                <a:cs typeface="Calibri" pitchFamily="34" charset="-120"/>
               </a:rPr>
               <a:t>fix bugs, optimize onboarding flow</a:t>
             </a:r>
@@ -3965,9 +3965,9 @@
                 <a:solidFill>
                   <a:srgbClr val="FFD700"/>
                 </a:solidFill>
-                <a:latin typeface="Carlito" pitchFamily="34" charset="0"/>
-                <a:ea typeface="Carlito" pitchFamily="34" charset="-122"/>
-                <a:cs typeface="Carlito" pitchFamily="34" charset="-120"/>
+                <a:latin typeface="Calibri" pitchFamily="34" charset="0"/>
+                <a:ea typeface="Calibri" pitchFamily="34" charset="-122"/>
+                <a:cs typeface="Calibri" pitchFamily="34" charset="-120"/>
               </a:rPr>
               <a:t>MONTH 2</a:t>
             </a:r>
@@ -4055,9 +4055,9 @@
                 <a:solidFill>
                   <a:srgbClr val="FFFFFF"/>
                 </a:solidFill>
-                <a:latin typeface="Carlito" pitchFamily="34" charset="0"/>
-                <a:ea typeface="Carlito" pitchFamily="34" charset="-122"/>
-                <a:cs typeface="Carlito" pitchFamily="34" charset="-120"/>
+                <a:latin typeface="Calibri" pitchFamily="34" charset="0"/>
+                <a:ea typeface="Calibri" pitchFamily="34" charset="-122"/>
+                <a:cs typeface="Calibri" pitchFamily="34" charset="-120"/>
               </a:rPr>
               <a:t>Public Launch</a:t>
             </a:r>
@@ -4094,9 +4094,9 @@
                 <a:solidFill>
                   <a:srgbClr val="888888"/>
                 </a:solidFill>
-                <a:latin typeface="Carlito" pitchFamily="34" charset="0"/>
-                <a:ea typeface="Carlito" pitchFamily="34" charset="-122"/>
-                <a:cs typeface="Carlito" pitchFamily="34" charset="-120"/>
+                <a:latin typeface="Calibri" pitchFamily="34" charset="0"/>
+                <a:ea typeface="Calibri" pitchFamily="34" charset="-122"/>
+                <a:cs typeface="Calibri" pitchFamily="34" charset="-120"/>
               </a:rPr>
               <a:t>App Store live, social media blitz,</a:t>
             </a:r>
@@ -4111,9 +4111,9 @@
                 <a:solidFill>
                   <a:srgbClr val="888888"/>
                 </a:solidFill>
-                <a:latin typeface="Carlito" pitchFamily="34" charset="0"/>
-                <a:ea typeface="Carlito" pitchFamily="34" charset="-122"/>
-                <a:cs typeface="Carlito" pitchFamily="34" charset="-120"/>
+                <a:latin typeface="Calibri" pitchFamily="34" charset="0"/>
+                <a:ea typeface="Calibri" pitchFamily="34" charset="-122"/>
+                <a:cs typeface="Calibri" pitchFamily="34" charset="-120"/>
               </a:rPr>
               <a:t>influencer partnerships, PR campaign</a:t>
             </a:r>
@@ -4170,9 +4170,9 @@
                 <a:solidFill>
                   <a:srgbClr val="E94560"/>
                 </a:solidFill>
-                <a:latin typeface="Carlito" pitchFamily="34" charset="0"/>
-                <a:ea typeface="Carlito" pitchFamily="34" charset="-122"/>
-                <a:cs typeface="Carlito" pitchFamily="34" charset="-120"/>
+                <a:latin typeface="Calibri" pitchFamily="34" charset="0"/>
+                <a:ea typeface="Calibri" pitchFamily="34" charset="-122"/>
+                <a:cs typeface="Calibri" pitchFamily="34" charset="-120"/>
               </a:rPr>
               <a:t>MONTH 3-6</a:t>
             </a:r>
@@ -4260,9 +4260,9 @@
                 <a:solidFill>
                   <a:srgbClr val="FFFFFF"/>
                 </a:solidFill>
-                <a:latin typeface="Carlito" pitchFamily="34" charset="0"/>
-                <a:ea typeface="Carlito" pitchFamily="34" charset="-122"/>
-                <a:cs typeface="Carlito" pitchFamily="34" charset="-120"/>
+                <a:latin typeface="Calibri" pitchFamily="34" charset="0"/>
+                <a:ea typeface="Calibri" pitchFamily="34" charset="-122"/>
+                <a:cs typeface="Calibri" pitchFamily="34" charset="-120"/>
               </a:rPr>
               <a:t>Scale &amp; Optimize</a:t>
             </a:r>
@@ -4299,9 +4299,9 @@
                 <a:solidFill>
                   <a:srgbClr val="888888"/>
                 </a:solidFill>
-                <a:latin typeface="Carlito" pitchFamily="34" charset="0"/>
-                <a:ea typeface="Carlito" pitchFamily="34" charset="-122"/>
-                <a:cs typeface="Carlito" pitchFamily="34" charset="-120"/>
+                <a:latin typeface="Calibri" pitchFamily="34" charset="0"/>
+                <a:ea typeface="Calibri" pitchFamily="34" charset="-122"/>
+                <a:cs typeface="Calibri" pitchFamily="34" charset="-120"/>
               </a:rPr>
               <a:t>ASO optimization, A/B pricing tests,</a:t>
             </a:r>
@@ -4316,9 +4316,9 @@
                 <a:solidFill>
                   <a:srgbClr val="888888"/>
                 </a:solidFill>
-                <a:latin typeface="Carlito" pitchFamily="34" charset="0"/>
-                <a:ea typeface="Carlito" pitchFamily="34" charset="-122"/>
-                <a:cs typeface="Carlito" pitchFamily="34" charset="-120"/>
+                <a:latin typeface="Calibri" pitchFamily="34" charset="0"/>
+                <a:ea typeface="Calibri" pitchFamily="34" charset="-122"/>
+                <a:cs typeface="Calibri" pitchFamily="34" charset="-120"/>
               </a:rPr>
               <a:t>Apple Watch, HealthKit integration</a:t>
             </a:r>
@@ -4375,9 +4375,9 @@
                 <a:solidFill>
                   <a:srgbClr val="7C3AED"/>
                 </a:solidFill>
-                <a:latin typeface="Carlito" pitchFamily="34" charset="0"/>
-                <a:ea typeface="Carlito" pitchFamily="34" charset="-122"/>
-                <a:cs typeface="Carlito" pitchFamily="34" charset="-120"/>
+                <a:latin typeface="Calibri" pitchFamily="34" charset="0"/>
+                <a:ea typeface="Calibri" pitchFamily="34" charset="-122"/>
+                <a:cs typeface="Calibri" pitchFamily="34" charset="-120"/>
               </a:rPr>
               <a:t>MONTH 6+</a:t>
             </a:r>
@@ -4465,9 +4465,9 @@
                 <a:solidFill>
                   <a:srgbClr val="FFFFFF"/>
                 </a:solidFill>
-                <a:latin typeface="Carlito" pitchFamily="34" charset="0"/>
-                <a:ea typeface="Carlito" pitchFamily="34" charset="-122"/>
-                <a:cs typeface="Carlito" pitchFamily="34" charset="-120"/>
+                <a:latin typeface="Calibri" pitchFamily="34" charset="0"/>
+                <a:ea typeface="Calibri" pitchFamily="34" charset="-122"/>
+                <a:cs typeface="Calibri" pitchFamily="34" charset="-120"/>
               </a:rPr>
               <a:t>Enterprise &amp; Growth</a:t>
             </a:r>
@@ -4504,9 +4504,9 @@
                 <a:solidFill>
                   <a:srgbClr val="888888"/>
                 </a:solidFill>
-                <a:latin typeface="Carlito" pitchFamily="34" charset="0"/>
-                <a:ea typeface="Carlito" pitchFamily="34" charset="-122"/>
-                <a:cs typeface="Carlito" pitchFamily="34" charset="-120"/>
+                <a:latin typeface="Calibri" pitchFamily="34" charset="0"/>
+                <a:ea typeface="Calibri" pitchFamily="34" charset="-122"/>
+                <a:cs typeface="Calibri" pitchFamily="34" charset="-120"/>
               </a:rPr>
               <a:t>B2B wellness packages, Android version,</a:t>
             </a:r>
@@ -4521,9 +4521,9 @@
                 <a:solidFill>
                   <a:srgbClr val="888888"/>
                 </a:solidFill>
-                <a:latin typeface="Carlito" pitchFamily="34" charset="0"/>
-                <a:ea typeface="Carlito" pitchFamily="34" charset="-122"/>
-                <a:cs typeface="Carlito" pitchFamily="34" charset="-120"/>
+                <a:latin typeface="Calibri" pitchFamily="34" charset="0"/>
+                <a:ea typeface="Calibri" pitchFamily="34" charset="-122"/>
+                <a:cs typeface="Calibri" pitchFamily="34" charset="-120"/>
               </a:rPr>
               <a:t>API marketplace, international expansion</a:t>
             </a:r>
@@ -4612,9 +4612,9 @@
                 <a:solidFill>
                   <a:srgbClr val="00C853"/>
                 </a:solidFill>
-                <a:latin typeface="Carlito" pitchFamily="34" charset="0"/>
-                <a:ea typeface="Carlito" pitchFamily="34" charset="-122"/>
-                <a:cs typeface="Carlito" pitchFamily="34" charset="-120"/>
+                <a:latin typeface="Calibri" pitchFamily="34" charset="0"/>
+                <a:ea typeface="Calibri" pitchFamily="34" charset="-122"/>
+                <a:cs typeface="Calibri" pitchFamily="34" charset="-120"/>
               </a:rPr>
               <a:t>FINANCIAL PROJECTIONS</a:t>
             </a:r>
@@ -4651,9 +4651,9 @@
                 <a:solidFill>
                   <a:srgbClr val="FFFFFF"/>
                 </a:solidFill>
-                <a:latin typeface="Liberation Sans" pitchFamily="34" charset="0"/>
-                <a:ea typeface="Liberation Sans" pitchFamily="34" charset="-122"/>
-                <a:cs typeface="Liberation Sans" pitchFamily="34" charset="-120"/>
+                <a:latin typeface="Arial Black" pitchFamily="34" charset="0"/>
+                <a:ea typeface="Arial Black" pitchFamily="34" charset="-122"/>
+                <a:cs typeface="Arial Black" pitchFamily="34" charset="-120"/>
               </a:rPr>
               <a:t>The Numbers Don't Lie</a:t>
             </a:r>
@@ -4706,9 +4706,9 @@
                 <a:solidFill>
                   <a:srgbClr val="888888"/>
                 </a:solidFill>
-                <a:latin typeface="Carlito" pitchFamily="34" charset="0"/>
-                <a:ea typeface="Carlito" pitchFamily="34" charset="-122"/>
-                <a:cs typeface="Carlito" pitchFamily="34" charset="-120"/>
+                <a:latin typeface="Calibri" pitchFamily="34" charset="0"/>
+                <a:ea typeface="Calibri" pitchFamily="34" charset="-122"/>
+                <a:cs typeface="Calibri" pitchFamily="34" charset="-120"/>
               </a:rPr>
               <a:t>Year 1 Users</a:t>
             </a:r>
@@ -4745,9 +4745,9 @@
                 <a:solidFill>
                   <a:srgbClr val="00D4FF"/>
                 </a:solidFill>
-                <a:latin typeface="Liberation Sans" pitchFamily="34" charset="0"/>
-                <a:ea typeface="Liberation Sans" pitchFamily="34" charset="-122"/>
-                <a:cs typeface="Liberation Sans" pitchFamily="34" charset="-120"/>
+                <a:latin typeface="Arial Black" pitchFamily="34" charset="0"/>
+                <a:ea typeface="Arial Black" pitchFamily="34" charset="-122"/>
+                <a:cs typeface="Arial Black" pitchFamily="34" charset="-120"/>
               </a:rPr>
               <a:t>50,000+</a:t>
             </a:r>
@@ -4784,9 +4784,9 @@
                 <a:solidFill>
                   <a:srgbClr val="888888"/>
                 </a:solidFill>
-                <a:latin typeface="Carlito" pitchFamily="34" charset="0"/>
-                <a:ea typeface="Carlito" pitchFamily="34" charset="-122"/>
-                <a:cs typeface="Carlito" pitchFamily="34" charset="-120"/>
+                <a:latin typeface="Calibri" pitchFamily="34" charset="0"/>
+                <a:ea typeface="Calibri" pitchFamily="34" charset="-122"/>
+                <a:cs typeface="Calibri" pitchFamily="34" charset="-120"/>
               </a:rPr>
               <a:t>Conversion Rate</a:t>
             </a:r>
@@ -4823,9 +4823,9 @@
                 <a:solidFill>
                   <a:srgbClr val="00C853"/>
                 </a:solidFill>
-                <a:latin typeface="Liberation Sans" pitchFamily="34" charset="0"/>
-                <a:ea typeface="Liberation Sans" pitchFamily="34" charset="-122"/>
-                <a:cs typeface="Liberation Sans" pitchFamily="34" charset="-120"/>
+                <a:latin typeface="Arial Black" pitchFamily="34" charset="0"/>
+                <a:ea typeface="Arial Black" pitchFamily="34" charset="-122"/>
+                <a:cs typeface="Arial Black" pitchFamily="34" charset="-120"/>
               </a:rPr>
               <a:t>8-12%</a:t>
             </a:r>
@@ -4862,9 +4862,9 @@
                 <a:solidFill>
                   <a:srgbClr val="888888"/>
                 </a:solidFill>
-                <a:latin typeface="Carlito" pitchFamily="34" charset="0"/>
-                <a:ea typeface="Carlito" pitchFamily="34" charset="-122"/>
-                <a:cs typeface="Carlito" pitchFamily="34" charset="-120"/>
+                <a:latin typeface="Calibri" pitchFamily="34" charset="0"/>
+                <a:ea typeface="Calibri" pitchFamily="34" charset="-122"/>
+                <a:cs typeface="Calibri" pitchFamily="34" charset="-120"/>
               </a:rPr>
               <a:t>Monthly ARPU</a:t>
             </a:r>
@@ -4901,9 +4901,9 @@
                 <a:solidFill>
                   <a:srgbClr val="FFD700"/>
                 </a:solidFill>
-                <a:latin typeface="Liberation Sans" pitchFamily="34" charset="0"/>
-                <a:ea typeface="Liberation Sans" pitchFamily="34" charset="-122"/>
-                <a:cs typeface="Liberation Sans" pitchFamily="34" charset="-120"/>
+                <a:latin typeface="Arial Black" pitchFamily="34" charset="0"/>
+                <a:ea typeface="Arial Black" pitchFamily="34" charset="-122"/>
+                <a:cs typeface="Arial Black" pitchFamily="34" charset="-120"/>
               </a:rPr>
               <a:t>$8.50</a:t>
             </a:r>
@@ -4940,9 +4940,9 @@
                 <a:solidFill>
                   <a:srgbClr val="888888"/>
                 </a:solidFill>
-                <a:latin typeface="Carlito" pitchFamily="34" charset="0"/>
-                <a:ea typeface="Carlito" pitchFamily="34" charset="-122"/>
-                <a:cs typeface="Carlito" pitchFamily="34" charset="-120"/>
+                <a:latin typeface="Calibri" pitchFamily="34" charset="0"/>
+                <a:ea typeface="Calibri" pitchFamily="34" charset="-122"/>
+                <a:cs typeface="Calibri" pitchFamily="34" charset="-120"/>
               </a:rPr>
               <a:t>Year 1 ARR</a:t>
             </a:r>
@@ -4979,9 +4979,9 @@
                 <a:solidFill>
                   <a:srgbClr val="E94560"/>
                 </a:solidFill>
-                <a:latin typeface="Liberation Sans" pitchFamily="34" charset="0"/>
-                <a:ea typeface="Liberation Sans" pitchFamily="34" charset="-122"/>
-                <a:cs typeface="Liberation Sans" pitchFamily="34" charset="-120"/>
+                <a:latin typeface="Arial Black" pitchFamily="34" charset="0"/>
+                <a:ea typeface="Arial Black" pitchFamily="34" charset="-122"/>
+                <a:cs typeface="Arial Black" pitchFamily="34" charset="-120"/>
               </a:rPr>
               <a:t>$1.8M</a:t>
             </a:r>
@@ -5018,9 +5018,9 @@
                 <a:solidFill>
                   <a:srgbClr val="888888"/>
                 </a:solidFill>
-                <a:latin typeface="Carlito" pitchFamily="34" charset="0"/>
-                <a:ea typeface="Carlito" pitchFamily="34" charset="-122"/>
-                <a:cs typeface="Carlito" pitchFamily="34" charset="-120"/>
+                <a:latin typeface="Calibri" pitchFamily="34" charset="0"/>
+                <a:ea typeface="Calibri" pitchFamily="34" charset="-122"/>
+                <a:cs typeface="Calibri" pitchFamily="34" charset="-120"/>
               </a:rPr>
               <a:t>Year 2 ARR</a:t>
             </a:r>
@@ -5057,9 +5057,9 @@
                 <a:solidFill>
                   <a:srgbClr val="FFD700"/>
                 </a:solidFill>
-                <a:latin typeface="Liberation Sans" pitchFamily="34" charset="0"/>
-                <a:ea typeface="Liberation Sans" pitchFamily="34" charset="-122"/>
-                <a:cs typeface="Liberation Sans" pitchFamily="34" charset="-120"/>
+                <a:latin typeface="Arial Black" pitchFamily="34" charset="0"/>
+                <a:ea typeface="Arial Black" pitchFamily="34" charset="-122"/>
+                <a:cs typeface="Arial Black" pitchFamily="34" charset="-120"/>
               </a:rPr>
               <a:t>$9.6M</a:t>
             </a:r>
@@ -5096,9 +5096,9 @@
                 <a:solidFill>
                   <a:srgbClr val="888888"/>
                 </a:solidFill>
-                <a:latin typeface="Carlito" pitchFamily="34" charset="0"/>
-                <a:ea typeface="Carlito" pitchFamily="34" charset="-122"/>
-                <a:cs typeface="Carlito" pitchFamily="34" charset="-120"/>
+                <a:latin typeface="Calibri" pitchFamily="34" charset="0"/>
+                <a:ea typeface="Calibri" pitchFamily="34" charset="-122"/>
+                <a:cs typeface="Calibri" pitchFamily="34" charset="-120"/>
               </a:rPr>
               <a:t>LTV:CAC Ratio</a:t>
             </a:r>
@@ -5135,9 +5135,9 @@
                 <a:solidFill>
                   <a:srgbClr val="00C853"/>
                 </a:solidFill>
-                <a:latin typeface="Liberation Sans" pitchFamily="34" charset="0"/>
-                <a:ea typeface="Liberation Sans" pitchFamily="34" charset="-122"/>
-                <a:cs typeface="Liberation Sans" pitchFamily="34" charset="-120"/>
+                <a:latin typeface="Arial Black" pitchFamily="34" charset="0"/>
+                <a:ea typeface="Arial Black" pitchFamily="34" charset="-122"/>
+                <a:cs typeface="Arial Black" pitchFamily="34" charset="-120"/>
               </a:rPr>
               <a:t>5:1</a:t>
             </a:r>
@@ -5174,9 +5174,9 @@
                 <a:solidFill>
                   <a:srgbClr val="888888"/>
                 </a:solidFill>
-                <a:latin typeface="Carlito" pitchFamily="34" charset="0"/>
-                <a:ea typeface="Carlito" pitchFamily="34" charset="-122"/>
-                <a:cs typeface="Carlito" pitchFamily="34" charset="-120"/>
+                <a:latin typeface="Calibri" pitchFamily="34" charset="0"/>
+                <a:ea typeface="Calibri" pitchFamily="34" charset="-122"/>
+                <a:cs typeface="Calibri" pitchFamily="34" charset="-120"/>
               </a:rPr>
               <a:t>Conservative estimates based on 2% market penetration in target demographic</a:t>
             </a:r>
@@ -5289,9 +5289,9 @@
                 <a:solidFill>
                   <a:srgbClr val="FFFFFF"/>
                 </a:solidFill>
-                <a:latin typeface="Liberation Sans" pitchFamily="34" charset="0"/>
-                <a:ea typeface="Liberation Sans" pitchFamily="34" charset="-122"/>
-                <a:cs typeface="Liberation Sans" pitchFamily="34" charset="-120"/>
+                <a:latin typeface="Arial Black" pitchFamily="34" charset="0"/>
+                <a:ea typeface="Arial Black" pitchFamily="34" charset="-122"/>
+                <a:cs typeface="Arial Black" pitchFamily="34" charset="-120"/>
               </a:rPr>
               <a:t>JOIN THE 1%</a:t>
             </a:r>
@@ -5350,9 +5350,9 @@
                 <a:solidFill>
                   <a:srgbClr val="0A0A0A"/>
                 </a:solidFill>
-                <a:latin typeface="Liberation Sans" pitchFamily="34" charset="0"/>
-                <a:ea typeface="Liberation Sans" pitchFamily="34" charset="-122"/>
-                <a:cs typeface="Liberation Sans" pitchFamily="34" charset="-120"/>
+                <a:latin typeface="Arial Black" pitchFamily="34" charset="0"/>
+                <a:ea typeface="Arial Black" pitchFamily="34" charset="-122"/>
+                <a:cs typeface="Arial Black" pitchFamily="34" charset="-120"/>
               </a:rPr>
               <a:t>TOP PERFORMER</a:t>
             </a:r>
@@ -5389,9 +5389,9 @@
                 <a:solidFill>
                   <a:srgbClr val="CCCCCC"/>
                 </a:solidFill>
-                <a:latin typeface="Carlito" pitchFamily="34" charset="0"/>
-                <a:ea typeface="Carlito" pitchFamily="34" charset="-122"/>
-                <a:cs typeface="Carlito" pitchFamily="34" charset="-120"/>
+                <a:latin typeface="Calibri" pitchFamily="34" charset="0"/>
+                <a:ea typeface="Calibri" pitchFamily="34" charset="-122"/>
+                <a:cs typeface="Calibri" pitchFamily="34" charset="-120"/>
               </a:rPr>
               <a:t>The app is built. The market is ready. The only question is:</a:t>
             </a:r>
@@ -5428,9 +5428,9 @@
                 <a:solidFill>
                   <a:srgbClr val="D4A017"/>
                 </a:solidFill>
-                <a:latin typeface="Liberation Sans" pitchFamily="34" charset="0"/>
-                <a:ea typeface="Liberation Sans" pitchFamily="34" charset="-122"/>
-                <a:cs typeface="Liberation Sans" pitchFamily="34" charset="-120"/>
+                <a:latin typeface="Arial Black" pitchFamily="34" charset="0"/>
+                <a:ea typeface="Arial Black" pitchFamily="34" charset="-122"/>
+                <a:cs typeface="Arial Black" pitchFamily="34" charset="-120"/>
               </a:rPr>
               <a:t>Are you in?</a:t>
             </a:r>
@@ -5467,9 +5467,9 @@
                 <a:solidFill>
                   <a:srgbClr val="888888"/>
                 </a:solidFill>
-                <a:latin typeface="Carlito" pitchFamily="34" charset="0"/>
-                <a:ea typeface="Carlito" pitchFamily="34" charset="-122"/>
-                <a:cs typeface="Carlito" pitchFamily="34" charset="-120"/>
+                <a:latin typeface="Calibri" pitchFamily="34" charset="0"/>
+                <a:ea typeface="Calibri" pitchFamily="34" charset="-122"/>
+                <a:cs typeface="Calibri" pitchFamily="34" charset="-120"/>
               </a:rPr>
               <a:t>Mike  |  michaelperkins07@gmail.com  |  mj-superstars-app.onrender.com</a:t>
             </a:r>
@@ -5578,9 +5578,9 @@
                 <a:solidFill>
                   <a:srgbClr val="E94560"/>
                 </a:solidFill>
-                <a:latin typeface="Carlito" pitchFamily="34" charset="0"/>
-                <a:ea typeface="Carlito" pitchFamily="34" charset="-122"/>
-                <a:cs typeface="Carlito" pitchFamily="34" charset="-120"/>
+                <a:latin typeface="Calibri" pitchFamily="34" charset="0"/>
+                <a:ea typeface="Calibri" pitchFamily="34" charset="-122"/>
+                <a:cs typeface="Calibri" pitchFamily="34" charset="-120"/>
               </a:rPr>
               <a:t>THE PROBLEM</a:t>
             </a:r>
@@ -5617,9 +5617,9 @@
                 <a:solidFill>
                   <a:srgbClr val="FFFFFF"/>
                 </a:solidFill>
-                <a:latin typeface="Liberation Sans" pitchFamily="34" charset="0"/>
-                <a:ea typeface="Liberation Sans" pitchFamily="34" charset="-122"/>
-                <a:cs typeface="Liberation Sans" pitchFamily="34" charset="-120"/>
+                <a:latin typeface="Arial Black" pitchFamily="34" charset="0"/>
+                <a:ea typeface="Arial Black" pitchFamily="34" charset="-122"/>
+                <a:cs typeface="Arial Black" pitchFamily="34" charset="-120"/>
               </a:rPr>
               <a:t>99% of People Are Underperforming</a:t>
             </a:r>
@@ -5683,9 +5683,9 @@
                 <a:solidFill>
                   <a:srgbClr val="E94560"/>
                 </a:solidFill>
-                <a:latin typeface="Liberation Sans" pitchFamily="34" charset="0"/>
-                <a:ea typeface="Liberation Sans" pitchFamily="34" charset="-122"/>
-                <a:cs typeface="Liberation Sans" pitchFamily="34" charset="-120"/>
+                <a:latin typeface="Arial Black" pitchFamily="34" charset="0"/>
+                <a:ea typeface="Arial Black" pitchFamily="34" charset="-122"/>
+                <a:cs typeface="Arial Black" pitchFamily="34" charset="-120"/>
               </a:rPr>
               <a:t>77%</a:t>
             </a:r>
@@ -5722,9 +5722,9 @@
                 <a:solidFill>
                   <a:srgbClr val="CCCCCC"/>
                 </a:solidFill>
-                <a:latin typeface="Carlito" pitchFamily="34" charset="0"/>
-                <a:ea typeface="Carlito" pitchFamily="34" charset="-122"/>
-                <a:cs typeface="Carlito" pitchFamily="34" charset="-120"/>
+                <a:latin typeface="Calibri" pitchFamily="34" charset="0"/>
+                <a:ea typeface="Calibri" pitchFamily="34" charset="-122"/>
+                <a:cs typeface="Calibri" pitchFamily="34" charset="-120"/>
               </a:rPr>
               <a:t>of adults experience</a:t>
             </a:r>
@@ -5739,9 +5739,9 @@
                 <a:solidFill>
                   <a:srgbClr val="CCCCCC"/>
                 </a:solidFill>
-                <a:latin typeface="Carlito" pitchFamily="34" charset="0"/>
-                <a:ea typeface="Carlito" pitchFamily="34" charset="-122"/>
-                <a:cs typeface="Carlito" pitchFamily="34" charset="-120"/>
+                <a:latin typeface="Calibri" pitchFamily="34" charset="0"/>
+                <a:ea typeface="Calibri" pitchFamily="34" charset="-122"/>
+                <a:cs typeface="Calibri" pitchFamily="34" charset="-120"/>
               </a:rPr>
               <a:t>stress that affects</a:t>
             </a:r>
@@ -5756,9 +5756,9 @@
                 <a:solidFill>
                   <a:srgbClr val="CCCCCC"/>
                 </a:solidFill>
-                <a:latin typeface="Carlito" pitchFamily="34" charset="0"/>
-                <a:ea typeface="Carlito" pitchFamily="34" charset="-122"/>
-                <a:cs typeface="Carlito" pitchFamily="34" charset="-120"/>
+                <a:latin typeface="Calibri" pitchFamily="34" charset="0"/>
+                <a:ea typeface="Calibri" pitchFamily="34" charset="-122"/>
+                <a:cs typeface="Calibri" pitchFamily="34" charset="-120"/>
               </a:rPr>
               <a:t>their physical health</a:t>
             </a:r>
@@ -5822,9 +5822,9 @@
                 <a:solidFill>
                   <a:srgbClr val="D4A017"/>
                 </a:solidFill>
-                <a:latin typeface="Liberation Sans" pitchFamily="34" charset="0"/>
-                <a:ea typeface="Liberation Sans" pitchFamily="34" charset="-122"/>
-                <a:cs typeface="Liberation Sans" pitchFamily="34" charset="-120"/>
+                <a:latin typeface="Arial Black" pitchFamily="34" charset="0"/>
+                <a:ea typeface="Arial Black" pitchFamily="34" charset="-122"/>
+                <a:cs typeface="Arial Black" pitchFamily="34" charset="-120"/>
               </a:rPr>
               <a:t>$322B</a:t>
             </a:r>
@@ -5861,9 +5861,9 @@
                 <a:solidFill>
                   <a:srgbClr val="CCCCCC"/>
                 </a:solidFill>
-                <a:latin typeface="Carlito" pitchFamily="34" charset="0"/>
-                <a:ea typeface="Carlito" pitchFamily="34" charset="-122"/>
-                <a:cs typeface="Carlito" pitchFamily="34" charset="-120"/>
+                <a:latin typeface="Calibri" pitchFamily="34" charset="0"/>
+                <a:ea typeface="Calibri" pitchFamily="34" charset="-122"/>
+                <a:cs typeface="Calibri" pitchFamily="34" charset="-120"/>
               </a:rPr>
               <a:t>lost annually to</a:t>
             </a:r>
@@ -5878,9 +5878,9 @@
                 <a:solidFill>
                   <a:srgbClr val="CCCCCC"/>
                 </a:solidFill>
-                <a:latin typeface="Carlito" pitchFamily="34" charset="0"/>
-                <a:ea typeface="Carlito" pitchFamily="34" charset="-122"/>
-                <a:cs typeface="Carlito" pitchFamily="34" charset="-120"/>
+                <a:latin typeface="Calibri" pitchFamily="34" charset="0"/>
+                <a:ea typeface="Calibri" pitchFamily="34" charset="-122"/>
+                <a:cs typeface="Calibri" pitchFamily="34" charset="-120"/>
               </a:rPr>
               <a:t>stress-related</a:t>
             </a:r>
@@ -5895,9 +5895,9 @@
                 <a:solidFill>
                   <a:srgbClr val="CCCCCC"/>
                 </a:solidFill>
-                <a:latin typeface="Carlito" pitchFamily="34" charset="0"/>
-                <a:ea typeface="Carlito" pitchFamily="34" charset="-122"/>
-                <a:cs typeface="Carlito" pitchFamily="34" charset="-120"/>
+                <a:latin typeface="Calibri" pitchFamily="34" charset="0"/>
+                <a:ea typeface="Calibri" pitchFamily="34" charset="-122"/>
+                <a:cs typeface="Calibri" pitchFamily="34" charset="-120"/>
               </a:rPr>
               <a:t>workplace issues</a:t>
             </a:r>
@@ -5961,9 +5961,9 @@
                 <a:solidFill>
                   <a:srgbClr val="00D4FF"/>
                 </a:solidFill>
-                <a:latin typeface="Liberation Sans" pitchFamily="34" charset="0"/>
-                <a:ea typeface="Liberation Sans" pitchFamily="34" charset="-122"/>
-                <a:cs typeface="Liberation Sans" pitchFamily="34" charset="-120"/>
+                <a:latin typeface="Arial Black" pitchFamily="34" charset="0"/>
+                <a:ea typeface="Arial Black" pitchFamily="34" charset="-122"/>
+                <a:cs typeface="Arial Black" pitchFamily="34" charset="-120"/>
               </a:rPr>
               <a:t>1 in 5</a:t>
             </a:r>
@@ -6000,9 +6000,9 @@
                 <a:solidFill>
                   <a:srgbClr val="CCCCCC"/>
                 </a:solidFill>
-                <a:latin typeface="Carlito" pitchFamily="34" charset="0"/>
-                <a:ea typeface="Carlito" pitchFamily="34" charset="-122"/>
-                <a:cs typeface="Carlito" pitchFamily="34" charset="-120"/>
+                <a:latin typeface="Calibri" pitchFamily="34" charset="0"/>
+                <a:ea typeface="Calibri" pitchFamily="34" charset="-122"/>
+                <a:cs typeface="Calibri" pitchFamily="34" charset="-120"/>
               </a:rPr>
               <a:t>adults experience</a:t>
             </a:r>
@@ -6017,9 +6017,9 @@
                 <a:solidFill>
                   <a:srgbClr val="CCCCCC"/>
                 </a:solidFill>
-                <a:latin typeface="Carlito" pitchFamily="34" charset="0"/>
-                <a:ea typeface="Carlito" pitchFamily="34" charset="-122"/>
-                <a:cs typeface="Carlito" pitchFamily="34" charset="-120"/>
+                <a:latin typeface="Calibri" pitchFamily="34" charset="0"/>
+                <a:ea typeface="Calibri" pitchFamily="34" charset="-122"/>
+                <a:cs typeface="Calibri" pitchFamily="34" charset="-120"/>
               </a:rPr>
               <a:t>a mental illness</a:t>
             </a:r>
@@ -6034,9 +6034,9 @@
                 <a:solidFill>
                   <a:srgbClr val="CCCCCC"/>
                 </a:solidFill>
-                <a:latin typeface="Carlito" pitchFamily="34" charset="0"/>
-                <a:ea typeface="Carlito" pitchFamily="34" charset="-122"/>
-                <a:cs typeface="Carlito" pitchFamily="34" charset="-120"/>
+                <a:latin typeface="Calibri" pitchFamily="34" charset="0"/>
+                <a:ea typeface="Calibri" pitchFamily="34" charset="-122"/>
+                <a:cs typeface="Calibri" pitchFamily="34" charset="-120"/>
               </a:rPr>
               <a:t>each year</a:t>
             </a:r>
@@ -6073,9 +6073,9 @@
                 <a:solidFill>
                   <a:srgbClr val="D4A017"/>
                 </a:solidFill>
-                <a:latin typeface="Carlito" pitchFamily="34" charset="0"/>
-                <a:ea typeface="Carlito" pitchFamily="34" charset="-122"/>
-                <a:cs typeface="Carlito" pitchFamily="34" charset="-120"/>
+                <a:latin typeface="Calibri" pitchFamily="34" charset="0"/>
+                <a:ea typeface="Calibri" pitchFamily="34" charset="-122"/>
+                <a:cs typeface="Calibri" pitchFamily="34" charset="-120"/>
               </a:rPr>
               <a:t>They don't need another meditation app. They need a COACH.</a:t>
             </a:r>
@@ -6164,9 +6164,9 @@
                 <a:solidFill>
                   <a:srgbClr val="D4A017"/>
                 </a:solidFill>
-                <a:latin typeface="Carlito" pitchFamily="34" charset="0"/>
-                <a:ea typeface="Carlito" pitchFamily="34" charset="-122"/>
-                <a:cs typeface="Carlito" pitchFamily="34" charset="-120"/>
+                <a:latin typeface="Calibri" pitchFamily="34" charset="0"/>
+                <a:ea typeface="Calibri" pitchFamily="34" charset="-122"/>
+                <a:cs typeface="Calibri" pitchFamily="34" charset="-120"/>
               </a:rPr>
               <a:t>THE SOLUTION</a:t>
             </a:r>
@@ -6227,9 +6227,9 @@
                 <a:solidFill>
                   <a:srgbClr val="FFFFFF"/>
                 </a:solidFill>
-                <a:latin typeface="Liberation Sans" pitchFamily="34" charset="0"/>
-                <a:ea typeface="Liberation Sans" pitchFamily="34" charset="-122"/>
-                <a:cs typeface="Liberation Sans" pitchFamily="34" charset="-120"/>
+                <a:latin typeface="Arial Black" pitchFamily="34" charset="0"/>
+                <a:ea typeface="Arial Black" pitchFamily="34" charset="-122"/>
+                <a:cs typeface="Arial Black" pitchFamily="34" charset="-120"/>
               </a:rPr>
               <a:t>Your AI Mental Performance Coach</a:t>
             </a:r>
@@ -6266,9 +6266,9 @@
                 <a:solidFill>
                   <a:srgbClr val="CCCCCC"/>
                 </a:solidFill>
-                <a:latin typeface="Carlito" pitchFamily="34" charset="0"/>
-                <a:ea typeface="Carlito" pitchFamily="34" charset="-122"/>
-                <a:cs typeface="Carlito" pitchFamily="34" charset="-120"/>
+                <a:latin typeface="Calibri" pitchFamily="34" charset="0"/>
+                <a:ea typeface="Calibri" pitchFamily="34" charset="-122"/>
+                <a:cs typeface="Calibri" pitchFamily="34" charset="-120"/>
               </a:rPr>
               <a:t>Top Performer uses advanced AI to deliver personalized coaching that was previously only available to elite athletes, CEOs, and top-tier executives.</a:t>
             </a:r>
@@ -6356,9 +6356,9 @@
                 <a:solidFill>
                   <a:srgbClr val="FFFFFF"/>
                 </a:solidFill>
-                <a:latin typeface="Carlito" pitchFamily="34" charset="0"/>
-                <a:ea typeface="Carlito" pitchFamily="34" charset="-122"/>
-                <a:cs typeface="Carlito" pitchFamily="34" charset="-120"/>
+                <a:latin typeface="Calibri" pitchFamily="34" charset="0"/>
+                <a:ea typeface="Calibri" pitchFamily="34" charset="-122"/>
+                <a:cs typeface="Calibri" pitchFamily="34" charset="-120"/>
               </a:rPr>
               <a:t>AI Therapy Sessions</a:t>
             </a:r>
@@ -6395,9 +6395,9 @@
                 <a:solidFill>
                   <a:srgbClr val="888888"/>
                 </a:solidFill>
-                <a:latin typeface="Carlito" pitchFamily="34" charset="0"/>
-                <a:ea typeface="Carlito" pitchFamily="34" charset="-122"/>
-                <a:cs typeface="Carlito" pitchFamily="34" charset="-120"/>
+                <a:latin typeface="Calibri" pitchFamily="34" charset="0"/>
+                <a:ea typeface="Calibri" pitchFamily="34" charset="-122"/>
+                <a:cs typeface="Calibri" pitchFamily="34" charset="-120"/>
               </a:rPr>
               <a:t>On-demand cognitive behavioral coaching</a:t>
             </a:r>
@@ -6485,9 +6485,9 @@
                 <a:solidFill>
                   <a:srgbClr val="FFFFFF"/>
                 </a:solidFill>
-                <a:latin typeface="Carlito" pitchFamily="34" charset="0"/>
-                <a:ea typeface="Carlito" pitchFamily="34" charset="-122"/>
-                <a:cs typeface="Carlito" pitchFamily="34" charset="-120"/>
+                <a:latin typeface="Calibri" pitchFamily="34" charset="0"/>
+                <a:ea typeface="Calibri" pitchFamily="34" charset="-122"/>
+                <a:cs typeface="Calibri" pitchFamily="34" charset="-120"/>
               </a:rPr>
               <a:t>Daily Performance Drills</a:t>
             </a:r>
@@ -6524,9 +6524,9 @@
                 <a:solidFill>
                   <a:srgbClr val="888888"/>
                 </a:solidFill>
-                <a:latin typeface="Carlito" pitchFamily="34" charset="0"/>
-                <a:ea typeface="Carlito" pitchFamily="34" charset="-122"/>
-                <a:cs typeface="Carlito" pitchFamily="34" charset="-120"/>
+                <a:latin typeface="Calibri" pitchFamily="34" charset="0"/>
+                <a:ea typeface="Calibri" pitchFamily="34" charset="-122"/>
+                <a:cs typeface="Calibri" pitchFamily="34" charset="-120"/>
               </a:rPr>
               <a:t>Gamified challenges that build resilience</a:t>
             </a:r>
@@ -6614,9 +6614,9 @@
                 <a:solidFill>
                   <a:srgbClr val="FFFFFF"/>
                 </a:solidFill>
-                <a:latin typeface="Carlito" pitchFamily="34" charset="0"/>
-                <a:ea typeface="Carlito" pitchFamily="34" charset="-122"/>
-                <a:cs typeface="Carlito" pitchFamily="34" charset="-120"/>
+                <a:latin typeface="Calibri" pitchFamily="34" charset="0"/>
+                <a:ea typeface="Calibri" pitchFamily="34" charset="-122"/>
+                <a:cs typeface="Calibri" pitchFamily="34" charset="-120"/>
               </a:rPr>
               <a:t>Mood Intelligence</a:t>
             </a:r>
@@ -6653,9 +6653,9 @@
                 <a:solidFill>
                   <a:srgbClr val="888888"/>
                 </a:solidFill>
-                <a:latin typeface="Carlito" pitchFamily="34" charset="0"/>
-                <a:ea typeface="Carlito" pitchFamily="34" charset="-122"/>
-                <a:cs typeface="Carlito" pitchFamily="34" charset="-120"/>
+                <a:latin typeface="Calibri" pitchFamily="34" charset="0"/>
+                <a:ea typeface="Calibri" pitchFamily="34" charset="-122"/>
+                <a:cs typeface="Calibri" pitchFamily="34" charset="-120"/>
               </a:rPr>
               <a:t>Track patterns, predict triggers, optimize</a:t>
             </a:r>
@@ -6743,9 +6743,9 @@
                 <a:solidFill>
                   <a:srgbClr val="FFFFFF"/>
                 </a:solidFill>
-                <a:latin typeface="Carlito" pitchFamily="34" charset="0"/>
-                <a:ea typeface="Carlito" pitchFamily="34" charset="-122"/>
-                <a:cs typeface="Carlito" pitchFamily="34" charset="-120"/>
+                <a:latin typeface="Calibri" pitchFamily="34" charset="0"/>
+                <a:ea typeface="Calibri" pitchFamily="34" charset="-122"/>
+                <a:cs typeface="Calibri" pitchFamily="34" charset="-120"/>
               </a:rPr>
               <a:t>Achievement System</a:t>
             </a:r>
@@ -6782,9 +6782,9 @@
                 <a:solidFill>
                   <a:srgbClr val="888888"/>
                 </a:solidFill>
-                <a:latin typeface="Carlito" pitchFamily="34" charset="0"/>
-                <a:ea typeface="Carlito" pitchFamily="34" charset="-122"/>
-                <a:cs typeface="Carlito" pitchFamily="34" charset="-120"/>
+                <a:latin typeface="Calibri" pitchFamily="34" charset="0"/>
+                <a:ea typeface="Calibri" pitchFamily="34" charset="-122"/>
+                <a:cs typeface="Calibri" pitchFamily="34" charset="-120"/>
               </a:rPr>
               <a:t>XP, streaks, levels that keep you locked in</a:t>
             </a:r>
@@ -6872,9 +6872,9 @@
                 <a:solidFill>
                   <a:srgbClr val="FFFFFF"/>
                 </a:solidFill>
-                <a:latin typeface="Carlito" pitchFamily="34" charset="0"/>
-                <a:ea typeface="Carlito" pitchFamily="34" charset="-122"/>
-                <a:cs typeface="Carlito" pitchFamily="34" charset="-120"/>
+                <a:latin typeface="Calibri" pitchFamily="34" charset="0"/>
+                <a:ea typeface="Calibri" pitchFamily="34" charset="-122"/>
+                <a:cs typeface="Calibri" pitchFamily="34" charset="-120"/>
               </a:rPr>
               <a:t>Community of Winners</a:t>
             </a:r>
@@ -6911,9 +6911,9 @@
                 <a:solidFill>
                   <a:srgbClr val="888888"/>
                 </a:solidFill>
-                <a:latin typeface="Carlito" pitchFamily="34" charset="0"/>
-                <a:ea typeface="Carlito" pitchFamily="34" charset="-122"/>
-                <a:cs typeface="Carlito" pitchFamily="34" charset="-120"/>
+                <a:latin typeface="Calibri" pitchFamily="34" charset="0"/>
+                <a:ea typeface="Calibri" pitchFamily="34" charset="-122"/>
+                <a:cs typeface="Calibri" pitchFamily="34" charset="-120"/>
               </a:rPr>
               <a:t>Social feed with people who refuse to lose</a:t>
             </a:r>
@@ -7001,9 +7001,9 @@
                 <a:solidFill>
                   <a:srgbClr val="FFFFFF"/>
                 </a:solidFill>
-                <a:latin typeface="Carlito" pitchFamily="34" charset="0"/>
-                <a:ea typeface="Carlito" pitchFamily="34" charset="-122"/>
-                <a:cs typeface="Carlito" pitchFamily="34" charset="-120"/>
+                <a:latin typeface="Calibri" pitchFamily="34" charset="0"/>
+                <a:ea typeface="Calibri" pitchFamily="34" charset="-122"/>
+                <a:cs typeface="Calibri" pitchFamily="34" charset="-120"/>
               </a:rPr>
               <a:t>Smart Notifications</a:t>
             </a:r>
@@ -7040,9 +7040,9 @@
                 <a:solidFill>
                   <a:srgbClr val="888888"/>
                 </a:solidFill>
-                <a:latin typeface="Carlito" pitchFamily="34" charset="0"/>
-                <a:ea typeface="Carlito" pitchFamily="34" charset="-122"/>
-                <a:cs typeface="Carlito" pitchFamily="34" charset="-120"/>
+                <a:latin typeface="Calibri" pitchFamily="34" charset="0"/>
+                <a:ea typeface="Calibri" pitchFamily="34" charset="-122"/>
+                <a:cs typeface="Calibri" pitchFamily="34" charset="-120"/>
               </a:rPr>
               <a:t>AI-timed push alerts for peak moments</a:t>
             </a:r>
@@ -7131,9 +7131,9 @@
                 <a:solidFill>
                   <a:srgbClr val="00D4FF"/>
                 </a:solidFill>
-                <a:latin typeface="Carlito" pitchFamily="34" charset="0"/>
-                <a:ea typeface="Carlito" pitchFamily="34" charset="-122"/>
-                <a:cs typeface="Carlito" pitchFamily="34" charset="-120"/>
+                <a:latin typeface="Calibri" pitchFamily="34" charset="0"/>
+                <a:ea typeface="Calibri" pitchFamily="34" charset="-122"/>
+                <a:cs typeface="Calibri" pitchFamily="34" charset="-120"/>
               </a:rPr>
               <a:t>WHAT'S INSIDE</a:t>
             </a:r>
@@ -7170,9 +7170,9 @@
                 <a:solidFill>
                   <a:srgbClr val="FFFFFF"/>
                 </a:solidFill>
-                <a:latin typeface="Liberation Sans" pitchFamily="34" charset="0"/>
-                <a:ea typeface="Liberation Sans" pitchFamily="34" charset="-122"/>
-                <a:cs typeface="Liberation Sans" pitchFamily="34" charset="-120"/>
+                <a:latin typeface="Arial Black" pitchFamily="34" charset="0"/>
+                <a:ea typeface="Arial Black" pitchFamily="34" charset="-122"/>
+                <a:cs typeface="Arial Black" pitchFamily="34" charset="-120"/>
               </a:rPr>
               <a:t>9 Screens. Zero Fluff. All Performance.</a:t>
             </a:r>
@@ -7233,9 +7233,9 @@
                 <a:solidFill>
                   <a:srgbClr val="00D4FF"/>
                 </a:solidFill>
-                <a:latin typeface="Carlito" pitchFamily="34" charset="0"/>
-                <a:ea typeface="Carlito" pitchFamily="34" charset="-122"/>
-                <a:cs typeface="Carlito" pitchFamily="34" charset="-120"/>
+                <a:latin typeface="Calibri" pitchFamily="34" charset="0"/>
+                <a:ea typeface="Calibri" pitchFamily="34" charset="-122"/>
+                <a:cs typeface="Calibri" pitchFamily="34" charset="-120"/>
               </a:rPr>
               <a:t>AI Chat Coach</a:t>
             </a:r>
@@ -7272,9 +7272,9 @@
                 <a:solidFill>
                   <a:srgbClr val="888888"/>
                 </a:solidFill>
-                <a:latin typeface="Carlito" pitchFamily="34" charset="0"/>
-                <a:ea typeface="Carlito" pitchFamily="34" charset="-122"/>
-                <a:cs typeface="Carlito" pitchFamily="34" charset="-120"/>
+                <a:latin typeface="Calibri" pitchFamily="34" charset="0"/>
+                <a:ea typeface="Calibri" pitchFamily="34" charset="-122"/>
+                <a:cs typeface="Calibri" pitchFamily="34" charset="-120"/>
               </a:rPr>
               <a:t>Real-time CBT, motivational interviewing, and Socratic questioning. Context-aware. Remembers your story.</a:t>
             </a:r>
@@ -7335,9 +7335,9 @@
                 <a:solidFill>
                   <a:srgbClr val="E94560"/>
                 </a:solidFill>
-                <a:latin typeface="Carlito" pitchFamily="34" charset="0"/>
-                <a:ea typeface="Carlito" pitchFamily="34" charset="-122"/>
-                <a:cs typeface="Carlito" pitchFamily="34" charset="-120"/>
+                <a:latin typeface="Calibri" pitchFamily="34" charset="0"/>
+                <a:ea typeface="Calibri" pitchFamily="34" charset="-122"/>
+                <a:cs typeface="Calibri" pitchFamily="34" charset="-120"/>
               </a:rPr>
               <a:t>Mood Tracker</a:t>
             </a:r>
@@ -7374,9 +7374,9 @@
                 <a:solidFill>
                   <a:srgbClr val="888888"/>
                 </a:solidFill>
-                <a:latin typeface="Carlito" pitchFamily="34" charset="0"/>
-                <a:ea typeface="Carlito" pitchFamily="34" charset="-122"/>
-                <a:cs typeface="Carlito" pitchFamily="34" charset="-120"/>
+                <a:latin typeface="Calibri" pitchFamily="34" charset="0"/>
+                <a:ea typeface="Calibri" pitchFamily="34" charset="-122"/>
+                <a:cs typeface="Calibri" pitchFamily="34" charset="-120"/>
               </a:rPr>
               <a:t>Log moods, energy, sleep. AI detects patterns and predicts your best/worst days before they happen.</a:t>
             </a:r>
@@ -7437,9 +7437,9 @@
                 <a:solidFill>
                   <a:srgbClr val="D4A017"/>
                 </a:solidFill>
-                <a:latin typeface="Carlito" pitchFamily="34" charset="0"/>
-                <a:ea typeface="Carlito" pitchFamily="34" charset="-122"/>
-                <a:cs typeface="Carlito" pitchFamily="34" charset="-120"/>
+                <a:latin typeface="Calibri" pitchFamily="34" charset="0"/>
+                <a:ea typeface="Calibri" pitchFamily="34" charset="-122"/>
+                <a:cs typeface="Calibri" pitchFamily="34" charset="-120"/>
               </a:rPr>
               <a:t>Daily Challenges</a:t>
             </a:r>
@@ -7476,9 +7476,9 @@
                 <a:solidFill>
                   <a:srgbClr val="888888"/>
                 </a:solidFill>
-                <a:latin typeface="Carlito" pitchFamily="34" charset="0"/>
-                <a:ea typeface="Carlito" pitchFamily="34" charset="-122"/>
-                <a:cs typeface="Carlito" pitchFamily="34" charset="-120"/>
+                <a:latin typeface="Calibri" pitchFamily="34" charset="0"/>
+                <a:ea typeface="Calibri" pitchFamily="34" charset="-122"/>
+                <a:cs typeface="Calibri" pitchFamily="34" charset="-120"/>
               </a:rPr>
               <a:t>Flash challenges, streak bonuses, XP multipliers. Gamification that drives habit formation.</a:t>
             </a:r>
@@ -7539,9 +7539,9 @@
                 <a:solidFill>
                   <a:srgbClr val="00C853"/>
                 </a:solidFill>
-                <a:latin typeface="Carlito" pitchFamily="34" charset="0"/>
-                <a:ea typeface="Carlito" pitchFamily="34" charset="-122"/>
-                <a:cs typeface="Carlito" pitchFamily="34" charset="-120"/>
+                <a:latin typeface="Calibri" pitchFamily="34" charset="0"/>
+                <a:ea typeface="Calibri" pitchFamily="34" charset="-122"/>
+                <a:cs typeface="Calibri" pitchFamily="34" charset="-120"/>
               </a:rPr>
               <a:t>Journal + Prompts</a:t>
             </a:r>
@@ -7578,9 +7578,9 @@
                 <a:solidFill>
                   <a:srgbClr val="888888"/>
                 </a:solidFill>
-                <a:latin typeface="Carlito" pitchFamily="34" charset="0"/>
-                <a:ea typeface="Carlito" pitchFamily="34" charset="-122"/>
-                <a:cs typeface="Carlito" pitchFamily="34" charset="-120"/>
+                <a:latin typeface="Calibri" pitchFamily="34" charset="0"/>
+                <a:ea typeface="Calibri" pitchFamily="34" charset="-122"/>
+                <a:cs typeface="Calibri" pitchFamily="34" charset="-120"/>
               </a:rPr>
               <a:t>AI-generated reflection prompts based on YOUR patterns. Private, encrypted, powerful.</a:t>
             </a:r>
@@ -7641,9 +7641,9 @@
                 <a:solidFill>
                   <a:srgbClr val="00D4FF"/>
                 </a:solidFill>
-                <a:latin typeface="Carlito" pitchFamily="34" charset="0"/>
-                <a:ea typeface="Carlito" pitchFamily="34" charset="-122"/>
-                <a:cs typeface="Carlito" pitchFamily="34" charset="-120"/>
+                <a:latin typeface="Calibri" pitchFamily="34" charset="0"/>
+                <a:ea typeface="Calibri" pitchFamily="34" charset="-122"/>
+                <a:cs typeface="Calibri" pitchFamily="34" charset="-120"/>
               </a:rPr>
               <a:t>Social Feed</a:t>
             </a:r>
@@ -7680,9 +7680,9 @@
                 <a:solidFill>
                   <a:srgbClr val="888888"/>
                 </a:solidFill>
-                <a:latin typeface="Carlito" pitchFamily="34" charset="0"/>
-                <a:ea typeface="Carlito" pitchFamily="34" charset="-122"/>
-                <a:cs typeface="Carlito" pitchFamily="34" charset="-120"/>
+                <a:latin typeface="Calibri" pitchFamily="34" charset="0"/>
+                <a:ea typeface="Calibri" pitchFamily="34" charset="-122"/>
+                <a:cs typeface="Calibri" pitchFamily="34" charset="-120"/>
               </a:rPr>
               <a:t>Share wins, support others, see the leaderboard. Positive accountability from day one.</a:t>
             </a:r>
@@ -7743,9 +7743,9 @@
                 <a:solidFill>
                   <a:srgbClr val="FFD700"/>
                 </a:solidFill>
-                <a:latin typeface="Carlito" pitchFamily="34" charset="0"/>
-                <a:ea typeface="Carlito" pitchFamily="34" charset="-122"/>
-                <a:cs typeface="Carlito" pitchFamily="34" charset="-120"/>
+                <a:latin typeface="Calibri" pitchFamily="34" charset="0"/>
+                <a:ea typeface="Calibri" pitchFamily="34" charset="-122"/>
+                <a:cs typeface="Calibri" pitchFamily="34" charset="-120"/>
               </a:rPr>
               <a:t>Vision Board</a:t>
             </a:r>
@@ -7782,9 +7782,9 @@
                 <a:solidFill>
                   <a:srgbClr val="888888"/>
                 </a:solidFill>
-                <a:latin typeface="Carlito" pitchFamily="34" charset="0"/>
-                <a:ea typeface="Carlito" pitchFamily="34" charset="-122"/>
-                <a:cs typeface="Carlito" pitchFamily="34" charset="-120"/>
+                <a:latin typeface="Calibri" pitchFamily="34" charset="0"/>
+                <a:ea typeface="Calibri" pitchFamily="34" charset="-122"/>
+                <a:cs typeface="Calibri" pitchFamily="34" charset="-120"/>
               </a:rPr>
               <a:t>Photo-powered goal visualization. Upload dreams, track progress, stay obsessed.</a:t>
             </a:r>
@@ -7845,9 +7845,9 @@
                 <a:solidFill>
                   <a:srgbClr val="E94560"/>
                 </a:solidFill>
-                <a:latin typeface="Carlito" pitchFamily="34" charset="0"/>
-                <a:ea typeface="Carlito" pitchFamily="34" charset="-122"/>
-                <a:cs typeface="Carlito" pitchFamily="34" charset="-120"/>
+                <a:latin typeface="Calibri" pitchFamily="34" charset="0"/>
+                <a:ea typeface="Calibri" pitchFamily="34" charset="-122"/>
+                <a:cs typeface="Calibri" pitchFamily="34" charset="-120"/>
               </a:rPr>
               <a:t>Smart Alerts</a:t>
             </a:r>
@@ -7884,9 +7884,9 @@
                 <a:solidFill>
                   <a:srgbClr val="888888"/>
                 </a:solidFill>
-                <a:latin typeface="Carlito" pitchFamily="34" charset="0"/>
-                <a:ea typeface="Carlito" pitchFamily="34" charset="-122"/>
-                <a:cs typeface="Carlito" pitchFamily="34" charset="-120"/>
+                <a:latin typeface="Calibri" pitchFamily="34" charset="0"/>
+                <a:ea typeface="Calibri" pitchFamily="34" charset="-122"/>
+                <a:cs typeface="Calibri" pitchFamily="34" charset="-120"/>
               </a:rPr>
               <a:t>AI-optimized push notifications. Right message, right time. Based on your behavior patterns.</a:t>
             </a:r>
@@ -7947,9 +7947,9 @@
                 <a:solidFill>
                   <a:srgbClr val="D4A017"/>
                 </a:solidFill>
-                <a:latin typeface="Carlito" pitchFamily="34" charset="0"/>
-                <a:ea typeface="Carlito" pitchFamily="34" charset="-122"/>
-                <a:cs typeface="Carlito" pitchFamily="34" charset="-120"/>
+                <a:latin typeface="Calibri" pitchFamily="34" charset="0"/>
+                <a:ea typeface="Calibri" pitchFamily="34" charset="-122"/>
+                <a:cs typeface="Calibri" pitchFamily="34" charset="-120"/>
               </a:rPr>
               <a:t>Premium Paywall</a:t>
             </a:r>
@@ -7986,9 +7986,9 @@
                 <a:solidFill>
                   <a:srgbClr val="888888"/>
                 </a:solidFill>
-                <a:latin typeface="Carlito" pitchFamily="34" charset="0"/>
-                <a:ea typeface="Carlito" pitchFamily="34" charset="-122"/>
-                <a:cs typeface="Carlito" pitchFamily="34" charset="-120"/>
+                <a:latin typeface="Calibri" pitchFamily="34" charset="0"/>
+                <a:ea typeface="Calibri" pitchFamily="34" charset="-122"/>
+                <a:cs typeface="Calibri" pitchFamily="34" charset="-120"/>
               </a:rPr>
               <a:t>Freemium model with $9.99/mo or $79.99/yr tiers. High-value features behind the gate.</a:t>
             </a:r>
@@ -8100,9 +8100,9 @@
                 <a:solidFill>
                   <a:srgbClr val="00C853"/>
                 </a:solidFill>
-                <a:latin typeface="Carlito" pitchFamily="34" charset="0"/>
-                <a:ea typeface="Carlito" pitchFamily="34" charset="-122"/>
-                <a:cs typeface="Carlito" pitchFamily="34" charset="-120"/>
+                <a:latin typeface="Calibri" pitchFamily="34" charset="0"/>
+                <a:ea typeface="Calibri" pitchFamily="34" charset="-122"/>
+                <a:cs typeface="Calibri" pitchFamily="34" charset="-120"/>
               </a:rPr>
               <a:t>MARKET OPPORTUNITY</a:t>
             </a:r>
@@ -8139,9 +8139,9 @@
                 <a:solidFill>
                   <a:srgbClr val="FFFFFF"/>
                 </a:solidFill>
-                <a:latin typeface="Liberation Sans" pitchFamily="34" charset="0"/>
-                <a:ea typeface="Liberation Sans" pitchFamily="34" charset="-122"/>
-                <a:cs typeface="Liberation Sans" pitchFamily="34" charset="-120"/>
+                <a:latin typeface="Arial Black" pitchFamily="34" charset="0"/>
+                <a:ea typeface="Arial Black" pitchFamily="34" charset="-122"/>
+                <a:cs typeface="Arial Black" pitchFamily="34" charset="-120"/>
               </a:rPr>
               <a:t>This Market Is Exploding</a:t>
             </a:r>
@@ -8229,9 +8229,9 @@
                 <a:solidFill>
                   <a:srgbClr val="00C853"/>
                 </a:solidFill>
-                <a:latin typeface="Liberation Sans" pitchFamily="34" charset="0"/>
-                <a:ea typeface="Liberation Sans" pitchFamily="34" charset="-122"/>
-                <a:cs typeface="Liberation Sans" pitchFamily="34" charset="-120"/>
+                <a:latin typeface="Arial Black" pitchFamily="34" charset="0"/>
+                <a:ea typeface="Arial Black" pitchFamily="34" charset="-122"/>
+                <a:cs typeface="Arial Black" pitchFamily="34" charset="-120"/>
               </a:rPr>
               <a:t>$13.5B</a:t>
             </a:r>
@@ -8268,9 +8268,9 @@
                 <a:solidFill>
                   <a:srgbClr val="CCCCCC"/>
                 </a:solidFill>
-                <a:latin typeface="Carlito" pitchFamily="34" charset="0"/>
-                <a:ea typeface="Carlito" pitchFamily="34" charset="-122"/>
-                <a:cs typeface="Carlito" pitchFamily="34" charset="-120"/>
+                <a:latin typeface="Calibri" pitchFamily="34" charset="0"/>
+                <a:ea typeface="Calibri" pitchFamily="34" charset="-122"/>
+                <a:cs typeface="Calibri" pitchFamily="34" charset="-120"/>
               </a:rPr>
               <a:t>Mental Health</a:t>
             </a:r>
@@ -8285,9 +8285,9 @@
                 <a:solidFill>
                   <a:srgbClr val="CCCCCC"/>
                 </a:solidFill>
-                <a:latin typeface="Carlito" pitchFamily="34" charset="0"/>
-                <a:ea typeface="Carlito" pitchFamily="34" charset="-122"/>
-                <a:cs typeface="Carlito" pitchFamily="34" charset="-120"/>
+                <a:latin typeface="Calibri" pitchFamily="34" charset="0"/>
+                <a:ea typeface="Calibri" pitchFamily="34" charset="-122"/>
+                <a:cs typeface="Calibri" pitchFamily="34" charset="-120"/>
               </a:rPr>
               <a:t>App Market</a:t>
             </a:r>
@@ -8302,9 +8302,9 @@
                 <a:solidFill>
                   <a:srgbClr val="CCCCCC"/>
                 </a:solidFill>
-                <a:latin typeface="Carlito" pitchFamily="34" charset="0"/>
-                <a:ea typeface="Carlito" pitchFamily="34" charset="-122"/>
-                <a:cs typeface="Carlito" pitchFamily="34" charset="-120"/>
+                <a:latin typeface="Calibri" pitchFamily="34" charset="0"/>
+                <a:ea typeface="Calibri" pitchFamily="34" charset="-122"/>
+                <a:cs typeface="Calibri" pitchFamily="34" charset="-120"/>
               </a:rPr>
               <a:t>(2025)</a:t>
             </a:r>
@@ -8341,9 +8341,9 @@
                 <a:solidFill>
                   <a:srgbClr val="888888"/>
                 </a:solidFill>
-                <a:latin typeface="Carlito" pitchFamily="34" charset="0"/>
-                <a:ea typeface="Carlito" pitchFamily="34" charset="-122"/>
-                <a:cs typeface="Carlito" pitchFamily="34" charset="-120"/>
+                <a:latin typeface="Calibri" pitchFamily="34" charset="0"/>
+                <a:ea typeface="Calibri" pitchFamily="34" charset="-122"/>
+                <a:cs typeface="Calibri" pitchFamily="34" charset="-120"/>
               </a:rPr>
               <a:t>Growing 15%+ CAGR</a:t>
             </a:r>
@@ -8431,9 +8431,9 @@
                 <a:solidFill>
                   <a:srgbClr val="00D4FF"/>
                 </a:solidFill>
-                <a:latin typeface="Liberation Sans" pitchFamily="34" charset="0"/>
-                <a:ea typeface="Liberation Sans" pitchFamily="34" charset="-122"/>
-                <a:cs typeface="Liberation Sans" pitchFamily="34" charset="-120"/>
+                <a:latin typeface="Arial Black" pitchFamily="34" charset="0"/>
+                <a:ea typeface="Arial Black" pitchFamily="34" charset="-122"/>
+                <a:cs typeface="Arial Black" pitchFamily="34" charset="-120"/>
               </a:rPr>
               <a:t>$5.1B</a:t>
             </a:r>
@@ -8470,9 +8470,9 @@
                 <a:solidFill>
                   <a:srgbClr val="CCCCCC"/>
                 </a:solidFill>
-                <a:latin typeface="Carlito" pitchFamily="34" charset="0"/>
-                <a:ea typeface="Carlito" pitchFamily="34" charset="-122"/>
-                <a:cs typeface="Carlito" pitchFamily="34" charset="-120"/>
+                <a:latin typeface="Calibri" pitchFamily="34" charset="0"/>
+                <a:ea typeface="Calibri" pitchFamily="34" charset="-122"/>
+                <a:cs typeface="Calibri" pitchFamily="34" charset="-120"/>
               </a:rPr>
               <a:t>Meditation &amp;</a:t>
             </a:r>
@@ -8487,9 +8487,9 @@
                 <a:solidFill>
                   <a:srgbClr val="CCCCCC"/>
                 </a:solidFill>
-                <a:latin typeface="Carlito" pitchFamily="34" charset="0"/>
-                <a:ea typeface="Carlito" pitchFamily="34" charset="-122"/>
-                <a:cs typeface="Carlito" pitchFamily="34" charset="-120"/>
+                <a:latin typeface="Calibri" pitchFamily="34" charset="0"/>
+                <a:ea typeface="Calibri" pitchFamily="34" charset="-122"/>
+                <a:cs typeface="Calibri" pitchFamily="34" charset="-120"/>
               </a:rPr>
               <a:t>Wellness Apps</a:t>
             </a:r>
@@ -8504,9 +8504,9 @@
                 <a:solidFill>
                   <a:srgbClr val="CCCCCC"/>
                 </a:solidFill>
-                <a:latin typeface="Carlito" pitchFamily="34" charset="0"/>
-                <a:ea typeface="Carlito" pitchFamily="34" charset="-122"/>
-                <a:cs typeface="Carlito" pitchFamily="34" charset="-120"/>
+                <a:latin typeface="Calibri" pitchFamily="34" charset="0"/>
+                <a:ea typeface="Calibri" pitchFamily="34" charset="-122"/>
+                <a:cs typeface="Calibri" pitchFamily="34" charset="-120"/>
               </a:rPr>
               <a:t>(2025)</a:t>
             </a:r>
@@ -8543,9 +8543,9 @@
                 <a:solidFill>
                   <a:srgbClr val="888888"/>
                 </a:solidFill>
-                <a:latin typeface="Carlito" pitchFamily="34" charset="0"/>
-                <a:ea typeface="Carlito" pitchFamily="34" charset="-122"/>
-                <a:cs typeface="Carlito" pitchFamily="34" charset="-120"/>
+                <a:latin typeface="Calibri" pitchFamily="34" charset="0"/>
+                <a:ea typeface="Calibri" pitchFamily="34" charset="-122"/>
+                <a:cs typeface="Calibri" pitchFamily="34" charset="-120"/>
               </a:rPr>
               <a:t>Headspace, Calm, etc.</a:t>
             </a:r>
@@ -8633,9 +8633,9 @@
                 <a:solidFill>
                   <a:srgbClr val="FFD700"/>
                 </a:solidFill>
-                <a:latin typeface="Liberation Sans" pitchFamily="34" charset="0"/>
-                <a:ea typeface="Liberation Sans" pitchFamily="34" charset="-122"/>
-                <a:cs typeface="Liberation Sans" pitchFamily="34" charset="-120"/>
+                <a:latin typeface="Arial Black" pitchFamily="34" charset="0"/>
+                <a:ea typeface="Arial Black" pitchFamily="34" charset="-122"/>
+                <a:cs typeface="Arial Black" pitchFamily="34" charset="-120"/>
               </a:rPr>
               <a:t>$1.2T</a:t>
             </a:r>
@@ -8672,9 +8672,9 @@
                 <a:solidFill>
                   <a:srgbClr val="CCCCCC"/>
                 </a:solidFill>
-                <a:latin typeface="Carlito" pitchFamily="34" charset="0"/>
-                <a:ea typeface="Carlito" pitchFamily="34" charset="-122"/>
-                <a:cs typeface="Carlito" pitchFamily="34" charset="-120"/>
+                <a:latin typeface="Calibri" pitchFamily="34" charset="0"/>
+                <a:ea typeface="Calibri" pitchFamily="34" charset="-122"/>
+                <a:cs typeface="Calibri" pitchFamily="34" charset="-120"/>
               </a:rPr>
               <a:t>Global Wellness</a:t>
             </a:r>
@@ -8689,9 +8689,9 @@
                 <a:solidFill>
                   <a:srgbClr val="CCCCCC"/>
                 </a:solidFill>
-                <a:latin typeface="Carlito" pitchFamily="34" charset="0"/>
-                <a:ea typeface="Carlito" pitchFamily="34" charset="-122"/>
-                <a:cs typeface="Carlito" pitchFamily="34" charset="-120"/>
+                <a:latin typeface="Calibri" pitchFamily="34" charset="0"/>
+                <a:ea typeface="Calibri" pitchFamily="34" charset="-122"/>
+                <a:cs typeface="Calibri" pitchFamily="34" charset="-120"/>
               </a:rPr>
               <a:t>Economy</a:t>
             </a:r>
@@ -8728,9 +8728,9 @@
                 <a:solidFill>
                   <a:srgbClr val="888888"/>
                 </a:solidFill>
-                <a:latin typeface="Carlito" pitchFamily="34" charset="0"/>
-                <a:ea typeface="Carlito" pitchFamily="34" charset="-122"/>
-                <a:cs typeface="Carlito" pitchFamily="34" charset="-120"/>
+                <a:latin typeface="Calibri" pitchFamily="34" charset="0"/>
+                <a:ea typeface="Calibri" pitchFamily="34" charset="-122"/>
+                <a:cs typeface="Calibri" pitchFamily="34" charset="-120"/>
               </a:rPr>
               <a:t>Mental wellness fastest</a:t>
             </a:r>
@@ -8767,9 +8767,9 @@
                 <a:solidFill>
                   <a:srgbClr val="D4A017"/>
                 </a:solidFill>
-                <a:latin typeface="Liberation Sans" pitchFamily="34" charset="0"/>
-                <a:ea typeface="Liberation Sans" pitchFamily="34" charset="-122"/>
-                <a:cs typeface="Liberation Sans" pitchFamily="34" charset="-120"/>
+                <a:latin typeface="Arial Black" pitchFamily="34" charset="0"/>
+                <a:ea typeface="Arial Black" pitchFamily="34" charset="-122"/>
+                <a:cs typeface="Arial Black" pitchFamily="34" charset="-120"/>
               </a:rPr>
               <a:t>WHY NOW?</a:t>
             </a:r>
@@ -8806,9 +8806,9 @@
                 <a:solidFill>
                   <a:srgbClr val="888888"/>
                 </a:solidFill>
-                <a:latin typeface="Carlito" pitchFamily="34" charset="0"/>
-                <a:ea typeface="Carlito" pitchFamily="34" charset="-122"/>
-                <a:cs typeface="Carlito" pitchFamily="34" charset="-120"/>
+                <a:latin typeface="Calibri" pitchFamily="34" charset="0"/>
+                <a:ea typeface="Calibri" pitchFamily="34" charset="-122"/>
+                <a:cs typeface="Calibri" pitchFamily="34" charset="-120"/>
               </a:rPr>
               <a:t>Post-pandemic mental health awareness at all-time high  |  AI technology finally capable of real coaching  |  Gen Z spending 2x more on mental wellness  |  Employer wellness budgets expanding 25% YoY</a:t>
             </a:r>
@@ -8897,9 +8897,9 @@
                 <a:solidFill>
                   <a:srgbClr val="E94560"/>
                 </a:solidFill>
-                <a:latin typeface="Carlito" pitchFamily="34" charset="0"/>
-                <a:ea typeface="Carlito" pitchFamily="34" charset="-122"/>
-                <a:cs typeface="Carlito" pitchFamily="34" charset="-120"/>
+                <a:latin typeface="Calibri" pitchFamily="34" charset="0"/>
+                <a:ea typeface="Calibri" pitchFamily="34" charset="-122"/>
+                <a:cs typeface="Calibri" pitchFamily="34" charset="-120"/>
               </a:rPr>
               <a:t>COMPETITIVE EDGE</a:t>
             </a:r>
@@ -8936,9 +8936,9 @@
                 <a:solidFill>
                   <a:srgbClr val="FFFFFF"/>
                 </a:solidFill>
-                <a:latin typeface="Liberation Sans" pitchFamily="34" charset="0"/>
-                <a:ea typeface="Liberation Sans" pitchFamily="34" charset="-122"/>
-                <a:cs typeface="Liberation Sans" pitchFamily="34" charset="-120"/>
+                <a:latin typeface="Arial Black" pitchFamily="34" charset="0"/>
+                <a:ea typeface="Arial Black" pitchFamily="34" charset="-122"/>
+                <a:cs typeface="Arial Black" pitchFamily="34" charset="-120"/>
               </a:rPr>
               <a:t>Why Top Performer Wins</a:t>
             </a:r>
@@ -8989,16 +8989,16 @@
                           <a:solidFill>
                             <a:srgbClr val="0A0A0A"/>
                           </a:solidFill>
-                          <a:latin typeface="Carlito" pitchFamily="34" charset="0"/>
-                          <a:ea typeface="Carlito" pitchFamily="34" charset="-122"/>
-                          <a:cs typeface="Carlito" pitchFamily="34" charset="-120"/>
+                          <a:latin typeface="Calibri" pitchFamily="34" charset="0"/>
+                          <a:ea typeface="Calibri" pitchFamily="34" charset="-122"/>
+                          <a:cs typeface="Calibri" pitchFamily="34" charset="-120"/>
                         </a:rPr>
                         <a:t>Feature</a:t>
                       </a:r>
                       <a:endParaRPr lang="en-US" sz="1200" dirty="0">
-                        <a:latin typeface="Carlito" charset="0"/>
-                        <a:ea typeface="Carlito" charset="0"/>
-                        <a:cs typeface="Carlito" charset="0"/>
+                        <a:latin typeface="Calibri" charset="0"/>
+                        <a:ea typeface="Calibri" charset="0"/>
+                        <a:cs typeface="Calibri" charset="0"/>
                       </a:endParaRPr>
                     </a:p>
                   </a:txBody>
@@ -9057,16 +9057,16 @@
                           <a:solidFill>
                             <a:srgbClr val="0A0A0A"/>
                           </a:solidFill>
-                          <a:latin typeface="Carlito" pitchFamily="34" charset="0"/>
-                          <a:ea typeface="Carlito" pitchFamily="34" charset="-122"/>
-                          <a:cs typeface="Carlito" pitchFamily="34" charset="-120"/>
+                          <a:latin typeface="Calibri" pitchFamily="34" charset="0"/>
+                          <a:ea typeface="Calibri" pitchFamily="34" charset="-122"/>
+                          <a:cs typeface="Calibri" pitchFamily="34" charset="-120"/>
                         </a:rPr>
                         <a:t>Top Performer</a:t>
                       </a:r>
                       <a:endParaRPr lang="en-US" sz="1200" dirty="0">
-                        <a:latin typeface="Carlito" charset="0"/>
-                        <a:ea typeface="Carlito" charset="0"/>
-                        <a:cs typeface="Carlito" charset="0"/>
+                        <a:latin typeface="Calibri" charset="0"/>
+                        <a:ea typeface="Calibri" charset="0"/>
+                        <a:cs typeface="Calibri" charset="0"/>
                       </a:endParaRPr>
                     </a:p>
                   </a:txBody>
@@ -9125,16 +9125,16 @@
                           <a:solidFill>
                             <a:srgbClr val="CCCCCC"/>
                           </a:solidFill>
-                          <a:latin typeface="Carlito" pitchFamily="34" charset="0"/>
-                          <a:ea typeface="Carlito" pitchFamily="34" charset="-122"/>
-                          <a:cs typeface="Carlito" pitchFamily="34" charset="-120"/>
+                          <a:latin typeface="Calibri" pitchFamily="34" charset="0"/>
+                          <a:ea typeface="Calibri" pitchFamily="34" charset="-122"/>
+                          <a:cs typeface="Calibri" pitchFamily="34" charset="-120"/>
                         </a:rPr>
                         <a:t>Headspace</a:t>
                       </a:r>
                       <a:endParaRPr lang="en-US" sz="1200" dirty="0">
-                        <a:latin typeface="Carlito" charset="0"/>
-                        <a:ea typeface="Carlito" charset="0"/>
-                        <a:cs typeface="Carlito" charset="0"/>
+                        <a:latin typeface="Calibri" charset="0"/>
+                        <a:ea typeface="Calibri" charset="0"/>
+                        <a:cs typeface="Calibri" charset="0"/>
                       </a:endParaRPr>
                     </a:p>
                   </a:txBody>
@@ -9193,16 +9193,16 @@
                           <a:solidFill>
                             <a:srgbClr val="CCCCCC"/>
                           </a:solidFill>
-                          <a:latin typeface="Carlito" pitchFamily="34" charset="0"/>
-                          <a:ea typeface="Carlito" pitchFamily="34" charset="-122"/>
-                          <a:cs typeface="Carlito" pitchFamily="34" charset="-120"/>
+                          <a:latin typeface="Calibri" pitchFamily="34" charset="0"/>
+                          <a:ea typeface="Calibri" pitchFamily="34" charset="-122"/>
+                          <a:cs typeface="Calibri" pitchFamily="34" charset="-120"/>
                         </a:rPr>
                         <a:t>BetterHelp</a:t>
                       </a:r>
                       <a:endParaRPr lang="en-US" sz="1200" dirty="0">
-                        <a:latin typeface="Carlito" charset="0"/>
-                        <a:ea typeface="Carlito" charset="0"/>
-                        <a:cs typeface="Carlito" charset="0"/>
+                        <a:latin typeface="Calibri" charset="0"/>
+                        <a:ea typeface="Calibri" charset="0"/>
+                        <a:cs typeface="Calibri" charset="0"/>
                       </a:endParaRPr>
                     </a:p>
                   </a:txBody>
@@ -9261,16 +9261,16 @@
                           <a:solidFill>
                             <a:srgbClr val="CCCCCC"/>
                           </a:solidFill>
-                          <a:latin typeface="Carlito" pitchFamily="34" charset="0"/>
-                          <a:ea typeface="Carlito" pitchFamily="34" charset="-122"/>
-                          <a:cs typeface="Carlito" pitchFamily="34" charset="-120"/>
+                          <a:latin typeface="Calibri" pitchFamily="34" charset="0"/>
+                          <a:ea typeface="Calibri" pitchFamily="34" charset="-122"/>
+                          <a:cs typeface="Calibri" pitchFamily="34" charset="-120"/>
                         </a:rPr>
                         <a:t>Calm</a:t>
                       </a:r>
                       <a:endParaRPr lang="en-US" sz="1200" dirty="0">
-                        <a:latin typeface="Carlito" charset="0"/>
-                        <a:ea typeface="Carlito" charset="0"/>
-                        <a:cs typeface="Carlito" charset="0"/>
+                        <a:latin typeface="Calibri" charset="0"/>
+                        <a:ea typeface="Calibri" charset="0"/>
+                        <a:cs typeface="Calibri" charset="0"/>
                       </a:endParaRPr>
                     </a:p>
                   </a:txBody>
@@ -9331,16 +9331,16 @@
                           <a:solidFill>
                             <a:srgbClr val="888888"/>
                           </a:solidFill>
-                          <a:latin typeface="Carlito" pitchFamily="34" charset="0"/>
-                          <a:ea typeface="Carlito" pitchFamily="34" charset="-122"/>
-                          <a:cs typeface="Carlito" pitchFamily="34" charset="-120"/>
+                          <a:latin typeface="Calibri" pitchFamily="34" charset="0"/>
+                          <a:ea typeface="Calibri" pitchFamily="34" charset="-122"/>
+                          <a:cs typeface="Calibri" pitchFamily="34" charset="-120"/>
                         </a:rPr>
                         <a:t>AI Coaching (Real Conversations)</a:t>
                       </a:r>
                       <a:endParaRPr lang="en-US" sz="1100" dirty="0">
-                        <a:latin typeface="Carlito" charset="0"/>
-                        <a:ea typeface="Carlito" charset="0"/>
-                        <a:cs typeface="Carlito" charset="0"/>
+                        <a:latin typeface="Calibri" charset="0"/>
+                        <a:ea typeface="Calibri" charset="0"/>
+                        <a:cs typeface="Calibri" charset="0"/>
                       </a:endParaRPr>
                     </a:p>
                   </a:txBody>
@@ -9399,16 +9399,16 @@
                           <a:solidFill>
                             <a:srgbClr val="00C853"/>
                           </a:solidFill>
-                          <a:latin typeface="Carlito" pitchFamily="34" charset="0"/>
-                          <a:ea typeface="Carlito" pitchFamily="34" charset="-122"/>
-                          <a:cs typeface="Carlito" pitchFamily="34" charset="-120"/>
+                          <a:latin typeface="Calibri" pitchFamily="34" charset="0"/>
+                          <a:ea typeface="Calibri" pitchFamily="34" charset="-122"/>
+                          <a:cs typeface="Calibri" pitchFamily="34" charset="-120"/>
                         </a:rPr>
                         <a:t>YES</a:t>
                       </a:r>
                       <a:endParaRPr lang="en-US" sz="1100" dirty="0">
-                        <a:latin typeface="Carlito" charset="0"/>
-                        <a:ea typeface="Carlito" charset="0"/>
-                        <a:cs typeface="Carlito" charset="0"/>
+                        <a:latin typeface="Calibri" charset="0"/>
+                        <a:ea typeface="Calibri" charset="0"/>
+                        <a:cs typeface="Calibri" charset="0"/>
                       </a:endParaRPr>
                     </a:p>
                   </a:txBody>
@@ -9467,16 +9467,16 @@
                           <a:solidFill>
                             <a:srgbClr val="888888"/>
                           </a:solidFill>
-                          <a:latin typeface="Carlito" pitchFamily="34" charset="0"/>
-                          <a:ea typeface="Carlito" pitchFamily="34" charset="-122"/>
-                          <a:cs typeface="Carlito" pitchFamily="34" charset="-120"/>
+                          <a:latin typeface="Calibri" pitchFamily="34" charset="0"/>
+                          <a:ea typeface="Calibri" pitchFamily="34" charset="-122"/>
+                          <a:cs typeface="Calibri" pitchFamily="34" charset="-120"/>
                         </a:rPr>
                         <a:t>No</a:t>
                       </a:r>
                       <a:endParaRPr lang="en-US" sz="1100" dirty="0">
-                        <a:latin typeface="Carlito" charset="0"/>
-                        <a:ea typeface="Carlito" charset="0"/>
-                        <a:cs typeface="Carlito" charset="0"/>
+                        <a:latin typeface="Calibri" charset="0"/>
+                        <a:ea typeface="Calibri" charset="0"/>
+                        <a:cs typeface="Calibri" charset="0"/>
                       </a:endParaRPr>
                     </a:p>
                   </a:txBody>
@@ -9535,16 +9535,16 @@
                           <a:solidFill>
                             <a:srgbClr val="888888"/>
                           </a:solidFill>
-                          <a:latin typeface="Carlito" pitchFamily="34" charset="0"/>
-                          <a:ea typeface="Carlito" pitchFamily="34" charset="-122"/>
-                          <a:cs typeface="Carlito" pitchFamily="34" charset="-120"/>
+                          <a:latin typeface="Calibri" pitchFamily="34" charset="0"/>
+                          <a:ea typeface="Calibri" pitchFamily="34" charset="-122"/>
+                          <a:cs typeface="Calibri" pitchFamily="34" charset="-120"/>
                         </a:rPr>
                         <a:t>No</a:t>
                       </a:r>
                       <a:endParaRPr lang="en-US" sz="1100" dirty="0">
-                        <a:latin typeface="Carlito" charset="0"/>
-                        <a:ea typeface="Carlito" charset="0"/>
-                        <a:cs typeface="Carlito" charset="0"/>
+                        <a:latin typeface="Calibri" charset="0"/>
+                        <a:ea typeface="Calibri" charset="0"/>
+                        <a:cs typeface="Calibri" charset="0"/>
                       </a:endParaRPr>
                     </a:p>
                   </a:txBody>
@@ -9603,16 +9603,16 @@
                           <a:solidFill>
                             <a:srgbClr val="888888"/>
                           </a:solidFill>
-                          <a:latin typeface="Carlito" pitchFamily="34" charset="0"/>
-                          <a:ea typeface="Carlito" pitchFamily="34" charset="-122"/>
-                          <a:cs typeface="Carlito" pitchFamily="34" charset="-120"/>
+                          <a:latin typeface="Calibri" pitchFamily="34" charset="0"/>
+                          <a:ea typeface="Calibri" pitchFamily="34" charset="-122"/>
+                          <a:cs typeface="Calibri" pitchFamily="34" charset="-120"/>
                         </a:rPr>
                         <a:t>No</a:t>
                       </a:r>
                       <a:endParaRPr lang="en-US" sz="1100" dirty="0">
-                        <a:latin typeface="Carlito" charset="0"/>
-                        <a:ea typeface="Carlito" charset="0"/>
-                        <a:cs typeface="Carlito" charset="0"/>
+                        <a:latin typeface="Calibri" charset="0"/>
+                        <a:ea typeface="Calibri" charset="0"/>
+                        <a:cs typeface="Calibri" charset="0"/>
                       </a:endParaRPr>
                     </a:p>
                   </a:txBody>
@@ -9673,16 +9673,16 @@
                           <a:solidFill>
                             <a:srgbClr val="888888"/>
                           </a:solidFill>
-                          <a:latin typeface="Carlito" pitchFamily="34" charset="0"/>
-                          <a:ea typeface="Carlito" pitchFamily="34" charset="-122"/>
-                          <a:cs typeface="Carlito" pitchFamily="34" charset="-120"/>
+                          <a:latin typeface="Calibri" pitchFamily="34" charset="0"/>
+                          <a:ea typeface="Calibri" pitchFamily="34" charset="-122"/>
+                          <a:cs typeface="Calibri" pitchFamily="34" charset="-120"/>
                         </a:rPr>
                         <a:t>Gamification (XP, Levels, Streaks)</a:t>
                       </a:r>
                       <a:endParaRPr lang="en-US" sz="1100" dirty="0">
-                        <a:latin typeface="Carlito" charset="0"/>
-                        <a:ea typeface="Carlito" charset="0"/>
-                        <a:cs typeface="Carlito" charset="0"/>
+                        <a:latin typeface="Calibri" charset="0"/>
+                        <a:ea typeface="Calibri" charset="0"/>
+                        <a:cs typeface="Calibri" charset="0"/>
                       </a:endParaRPr>
                     </a:p>
                   </a:txBody>
@@ -9741,16 +9741,16 @@
                           <a:solidFill>
                             <a:srgbClr val="00C853"/>
                           </a:solidFill>
-                          <a:latin typeface="Carlito" pitchFamily="34" charset="0"/>
-                          <a:ea typeface="Carlito" pitchFamily="34" charset="-122"/>
-                          <a:cs typeface="Carlito" pitchFamily="34" charset="-120"/>
+                          <a:latin typeface="Calibri" pitchFamily="34" charset="0"/>
+                          <a:ea typeface="Calibri" pitchFamily="34" charset="-122"/>
+                          <a:cs typeface="Calibri" pitchFamily="34" charset="-120"/>
                         </a:rPr>
                         <a:t>YES</a:t>
                       </a:r>
                       <a:endParaRPr lang="en-US" sz="1100" dirty="0">
-                        <a:latin typeface="Carlito" charset="0"/>
-                        <a:ea typeface="Carlito" charset="0"/>
-                        <a:cs typeface="Carlito" charset="0"/>
+                        <a:latin typeface="Calibri" charset="0"/>
+                        <a:ea typeface="Calibri" charset="0"/>
+                        <a:cs typeface="Calibri" charset="0"/>
                       </a:endParaRPr>
                     </a:p>
                   </a:txBody>
@@ -9809,16 +9809,16 @@
                           <a:solidFill>
                             <a:srgbClr val="888888"/>
                           </a:solidFill>
-                          <a:latin typeface="Carlito" pitchFamily="34" charset="0"/>
-                          <a:ea typeface="Carlito" pitchFamily="34" charset="-122"/>
-                          <a:cs typeface="Carlito" pitchFamily="34" charset="-120"/>
+                          <a:latin typeface="Calibri" pitchFamily="34" charset="0"/>
+                          <a:ea typeface="Calibri" pitchFamily="34" charset="-122"/>
+                          <a:cs typeface="Calibri" pitchFamily="34" charset="-120"/>
                         </a:rPr>
                         <a:t>Limited</a:t>
                       </a:r>
                       <a:endParaRPr lang="en-US" sz="1100" dirty="0">
-                        <a:latin typeface="Carlito" charset="0"/>
-                        <a:ea typeface="Carlito" charset="0"/>
-                        <a:cs typeface="Carlito" charset="0"/>
+                        <a:latin typeface="Calibri" charset="0"/>
+                        <a:ea typeface="Calibri" charset="0"/>
+                        <a:cs typeface="Calibri" charset="0"/>
                       </a:endParaRPr>
                     </a:p>
                   </a:txBody>
@@ -9877,16 +9877,16 @@
                           <a:solidFill>
                             <a:srgbClr val="888888"/>
                           </a:solidFill>
-                          <a:latin typeface="Carlito" pitchFamily="34" charset="0"/>
-                          <a:ea typeface="Carlito" pitchFamily="34" charset="-122"/>
-                          <a:cs typeface="Carlito" pitchFamily="34" charset="-120"/>
+                          <a:latin typeface="Calibri" pitchFamily="34" charset="0"/>
+                          <a:ea typeface="Calibri" pitchFamily="34" charset="-122"/>
+                          <a:cs typeface="Calibri" pitchFamily="34" charset="-120"/>
                         </a:rPr>
                         <a:t>No</a:t>
                       </a:r>
                       <a:endParaRPr lang="en-US" sz="1100" dirty="0">
-                        <a:latin typeface="Carlito" charset="0"/>
-                        <a:ea typeface="Carlito" charset="0"/>
-                        <a:cs typeface="Carlito" charset="0"/>
+                        <a:latin typeface="Calibri" charset="0"/>
+                        <a:ea typeface="Calibri" charset="0"/>
+                        <a:cs typeface="Calibri" charset="0"/>
                       </a:endParaRPr>
                     </a:p>
                   </a:txBody>
@@ -9945,16 +9945,16 @@
                           <a:solidFill>
                             <a:srgbClr val="888888"/>
                           </a:solidFill>
-                          <a:latin typeface="Carlito" pitchFamily="34" charset="0"/>
-                          <a:ea typeface="Carlito" pitchFamily="34" charset="-122"/>
-                          <a:cs typeface="Carlito" pitchFamily="34" charset="-120"/>
+                          <a:latin typeface="Calibri" pitchFamily="34" charset="0"/>
+                          <a:ea typeface="Calibri" pitchFamily="34" charset="-122"/>
+                          <a:cs typeface="Calibri" pitchFamily="34" charset="-120"/>
                         </a:rPr>
                         <a:t>Limited</a:t>
                       </a:r>
                       <a:endParaRPr lang="en-US" sz="1100" dirty="0">
-                        <a:latin typeface="Carlito" charset="0"/>
-                        <a:ea typeface="Carlito" charset="0"/>
-                        <a:cs typeface="Carlito" charset="0"/>
+                        <a:latin typeface="Calibri" charset="0"/>
+                        <a:ea typeface="Calibri" charset="0"/>
+                        <a:cs typeface="Calibri" charset="0"/>
                       </a:endParaRPr>
                     </a:p>
                   </a:txBody>
@@ -10015,16 +10015,16 @@
                           <a:solidFill>
                             <a:srgbClr val="888888"/>
                           </a:solidFill>
-                          <a:latin typeface="Carlito" pitchFamily="34" charset="0"/>
-                          <a:ea typeface="Carlito" pitchFamily="34" charset="-122"/>
-                          <a:cs typeface="Carlito" pitchFamily="34" charset="-120"/>
+                          <a:latin typeface="Calibri" pitchFamily="34" charset="0"/>
+                          <a:ea typeface="Calibri" pitchFamily="34" charset="-122"/>
+                          <a:cs typeface="Calibri" pitchFamily="34" charset="-120"/>
                         </a:rPr>
                         <a:t>Mood Intelligence + Prediction</a:t>
                       </a:r>
                       <a:endParaRPr lang="en-US" sz="1100" dirty="0">
-                        <a:latin typeface="Carlito" charset="0"/>
-                        <a:ea typeface="Carlito" charset="0"/>
-                        <a:cs typeface="Carlito" charset="0"/>
+                        <a:latin typeface="Calibri" charset="0"/>
+                        <a:ea typeface="Calibri" charset="0"/>
+                        <a:cs typeface="Calibri" charset="0"/>
                       </a:endParaRPr>
                     </a:p>
                   </a:txBody>
@@ -10083,16 +10083,16 @@
                           <a:solidFill>
                             <a:srgbClr val="00C853"/>
                           </a:solidFill>
-                          <a:latin typeface="Carlito" pitchFamily="34" charset="0"/>
-                          <a:ea typeface="Carlito" pitchFamily="34" charset="-122"/>
-                          <a:cs typeface="Carlito" pitchFamily="34" charset="-120"/>
+                          <a:latin typeface="Calibri" pitchFamily="34" charset="0"/>
+                          <a:ea typeface="Calibri" pitchFamily="34" charset="-122"/>
+                          <a:cs typeface="Calibri" pitchFamily="34" charset="-120"/>
                         </a:rPr>
                         <a:t>YES</a:t>
                       </a:r>
                       <a:endParaRPr lang="en-US" sz="1100" dirty="0">
-                        <a:latin typeface="Carlito" charset="0"/>
-                        <a:ea typeface="Carlito" charset="0"/>
-                        <a:cs typeface="Carlito" charset="0"/>
+                        <a:latin typeface="Calibri" charset="0"/>
+                        <a:ea typeface="Calibri" charset="0"/>
+                        <a:cs typeface="Calibri" charset="0"/>
                       </a:endParaRPr>
                     </a:p>
                   </a:txBody>
@@ -10151,16 +10151,16 @@
                           <a:solidFill>
                             <a:srgbClr val="888888"/>
                           </a:solidFill>
-                          <a:latin typeface="Carlito" pitchFamily="34" charset="0"/>
-                          <a:ea typeface="Carlito" pitchFamily="34" charset="-122"/>
-                          <a:cs typeface="Carlito" pitchFamily="34" charset="-120"/>
+                          <a:latin typeface="Calibri" pitchFamily="34" charset="0"/>
+                          <a:ea typeface="Calibri" pitchFamily="34" charset="-122"/>
+                          <a:cs typeface="Calibri" pitchFamily="34" charset="-120"/>
                         </a:rPr>
                         <a:t>No</a:t>
                       </a:r>
                       <a:endParaRPr lang="en-US" sz="1100" dirty="0">
-                        <a:latin typeface="Carlito" charset="0"/>
-                        <a:ea typeface="Carlito" charset="0"/>
-                        <a:cs typeface="Carlito" charset="0"/>
+                        <a:latin typeface="Calibri" charset="0"/>
+                        <a:ea typeface="Calibri" charset="0"/>
+                        <a:cs typeface="Calibri" charset="0"/>
                       </a:endParaRPr>
                     </a:p>
                   </a:txBody>
@@ -10219,16 +10219,16 @@
                           <a:solidFill>
                             <a:srgbClr val="888888"/>
                           </a:solidFill>
-                          <a:latin typeface="Carlito" pitchFamily="34" charset="0"/>
-                          <a:ea typeface="Carlito" pitchFamily="34" charset="-122"/>
-                          <a:cs typeface="Carlito" pitchFamily="34" charset="-120"/>
+                          <a:latin typeface="Calibri" pitchFamily="34" charset="0"/>
+                          <a:ea typeface="Calibri" pitchFamily="34" charset="-122"/>
+                          <a:cs typeface="Calibri" pitchFamily="34" charset="-120"/>
                         </a:rPr>
                         <a:t>No</a:t>
                       </a:r>
                       <a:endParaRPr lang="en-US" sz="1100" dirty="0">
-                        <a:latin typeface="Carlito" charset="0"/>
-                        <a:ea typeface="Carlito" charset="0"/>
-                        <a:cs typeface="Carlito" charset="0"/>
+                        <a:latin typeface="Calibri" charset="0"/>
+                        <a:ea typeface="Calibri" charset="0"/>
+                        <a:cs typeface="Calibri" charset="0"/>
                       </a:endParaRPr>
                     </a:p>
                   </a:txBody>
@@ -10287,16 +10287,16 @@
                           <a:solidFill>
                             <a:srgbClr val="888888"/>
                           </a:solidFill>
-                          <a:latin typeface="Carlito" pitchFamily="34" charset="0"/>
-                          <a:ea typeface="Carlito" pitchFamily="34" charset="-122"/>
-                          <a:cs typeface="Carlito" pitchFamily="34" charset="-120"/>
+                          <a:latin typeface="Calibri" pitchFamily="34" charset="0"/>
+                          <a:ea typeface="Calibri" pitchFamily="34" charset="-122"/>
+                          <a:cs typeface="Calibri" pitchFamily="34" charset="-120"/>
                         </a:rPr>
                         <a:t>No</a:t>
                       </a:r>
                       <a:endParaRPr lang="en-US" sz="1100" dirty="0">
-                        <a:latin typeface="Carlito" charset="0"/>
-                        <a:ea typeface="Carlito" charset="0"/>
-                        <a:cs typeface="Carlito" charset="0"/>
+                        <a:latin typeface="Calibri" charset="0"/>
+                        <a:ea typeface="Calibri" charset="0"/>
+                        <a:cs typeface="Calibri" charset="0"/>
                       </a:endParaRPr>
                     </a:p>
                   </a:txBody>
@@ -10357,16 +10357,16 @@
                           <a:solidFill>
                             <a:srgbClr val="888888"/>
                           </a:solidFill>
-                          <a:latin typeface="Carlito" pitchFamily="34" charset="0"/>
-                          <a:ea typeface="Carlito" pitchFamily="34" charset="-122"/>
-                          <a:cs typeface="Carlito" pitchFamily="34" charset="-120"/>
+                          <a:latin typeface="Calibri" pitchFamily="34" charset="0"/>
+                          <a:ea typeface="Calibri" pitchFamily="34" charset="-122"/>
+                          <a:cs typeface="Calibri" pitchFamily="34" charset="-120"/>
                         </a:rPr>
                         <a:t>Social Community &amp; Accountability</a:t>
                       </a:r>
                       <a:endParaRPr lang="en-US" sz="1100" dirty="0">
-                        <a:latin typeface="Carlito" charset="0"/>
-                        <a:ea typeface="Carlito" charset="0"/>
-                        <a:cs typeface="Carlito" charset="0"/>
+                        <a:latin typeface="Calibri" charset="0"/>
+                        <a:ea typeface="Calibri" charset="0"/>
+                        <a:cs typeface="Calibri" charset="0"/>
                       </a:endParaRPr>
                     </a:p>
                   </a:txBody>
@@ -10425,16 +10425,16 @@
                           <a:solidFill>
                             <a:srgbClr val="00C853"/>
                           </a:solidFill>
-                          <a:latin typeface="Carlito" pitchFamily="34" charset="0"/>
-                          <a:ea typeface="Carlito" pitchFamily="34" charset="-122"/>
-                          <a:cs typeface="Carlito" pitchFamily="34" charset="-120"/>
+                          <a:latin typeface="Calibri" pitchFamily="34" charset="0"/>
+                          <a:ea typeface="Calibri" pitchFamily="34" charset="-122"/>
+                          <a:cs typeface="Calibri" pitchFamily="34" charset="-120"/>
                         </a:rPr>
                         <a:t>YES</a:t>
                       </a:r>
                       <a:endParaRPr lang="en-US" sz="1100" dirty="0">
-                        <a:latin typeface="Carlito" charset="0"/>
-                        <a:ea typeface="Carlito" charset="0"/>
-                        <a:cs typeface="Carlito" charset="0"/>
+                        <a:latin typeface="Calibri" charset="0"/>
+                        <a:ea typeface="Calibri" charset="0"/>
+                        <a:cs typeface="Calibri" charset="0"/>
                       </a:endParaRPr>
                     </a:p>
                   </a:txBody>
@@ -10493,16 +10493,16 @@
                           <a:solidFill>
                             <a:srgbClr val="888888"/>
                           </a:solidFill>
-                          <a:latin typeface="Carlito" pitchFamily="34" charset="0"/>
-                          <a:ea typeface="Carlito" pitchFamily="34" charset="-122"/>
-                          <a:cs typeface="Carlito" pitchFamily="34" charset="-120"/>
+                          <a:latin typeface="Calibri" pitchFamily="34" charset="0"/>
+                          <a:ea typeface="Calibri" pitchFamily="34" charset="-122"/>
+                          <a:cs typeface="Calibri" pitchFamily="34" charset="-120"/>
                         </a:rPr>
                         <a:t>No</a:t>
                       </a:r>
                       <a:endParaRPr lang="en-US" sz="1100" dirty="0">
-                        <a:latin typeface="Carlito" charset="0"/>
-                        <a:ea typeface="Carlito" charset="0"/>
-                        <a:cs typeface="Carlito" charset="0"/>
+                        <a:latin typeface="Calibri" charset="0"/>
+                        <a:ea typeface="Calibri" charset="0"/>
+                        <a:cs typeface="Calibri" charset="0"/>
                       </a:endParaRPr>
                     </a:p>
                   </a:txBody>
@@ -10561,16 +10561,16 @@
                           <a:solidFill>
                             <a:srgbClr val="888888"/>
                           </a:solidFill>
-                          <a:latin typeface="Carlito" pitchFamily="34" charset="0"/>
-                          <a:ea typeface="Carlito" pitchFamily="34" charset="-122"/>
-                          <a:cs typeface="Carlito" pitchFamily="34" charset="-120"/>
+                          <a:latin typeface="Calibri" pitchFamily="34" charset="0"/>
+                          <a:ea typeface="Calibri" pitchFamily="34" charset="-122"/>
+                          <a:cs typeface="Calibri" pitchFamily="34" charset="-120"/>
                         </a:rPr>
                         <a:t>Forum only</a:t>
                       </a:r>
                       <a:endParaRPr lang="en-US" sz="1100" dirty="0">
-                        <a:latin typeface="Carlito" charset="0"/>
-                        <a:ea typeface="Carlito" charset="0"/>
-                        <a:cs typeface="Carlito" charset="0"/>
+                        <a:latin typeface="Calibri" charset="0"/>
+                        <a:ea typeface="Calibri" charset="0"/>
+                        <a:cs typeface="Calibri" charset="0"/>
                       </a:endParaRPr>
                     </a:p>
                   </a:txBody>
@@ -10629,16 +10629,16 @@
                           <a:solidFill>
                             <a:srgbClr val="888888"/>
                           </a:solidFill>
-                          <a:latin typeface="Carlito" pitchFamily="34" charset="0"/>
-                          <a:ea typeface="Carlito" pitchFamily="34" charset="-122"/>
-                          <a:cs typeface="Carlito" pitchFamily="34" charset="-120"/>
+                          <a:latin typeface="Calibri" pitchFamily="34" charset="0"/>
+                          <a:ea typeface="Calibri" pitchFamily="34" charset="-122"/>
+                          <a:cs typeface="Calibri" pitchFamily="34" charset="-120"/>
                         </a:rPr>
                         <a:t>No</a:t>
                       </a:r>
                       <a:endParaRPr lang="en-US" sz="1100" dirty="0">
-                        <a:latin typeface="Carlito" charset="0"/>
-                        <a:ea typeface="Carlito" charset="0"/>
-                        <a:cs typeface="Carlito" charset="0"/>
+                        <a:latin typeface="Calibri" charset="0"/>
+                        <a:ea typeface="Calibri" charset="0"/>
+                        <a:cs typeface="Calibri" charset="0"/>
                       </a:endParaRPr>
                     </a:p>
                   </a:txBody>
@@ -10699,16 +10699,16 @@
                           <a:solidFill>
                             <a:srgbClr val="888888"/>
                           </a:solidFill>
-                          <a:latin typeface="Carlito" pitchFamily="34" charset="0"/>
-                          <a:ea typeface="Carlito" pitchFamily="34" charset="-122"/>
-                          <a:cs typeface="Carlito" pitchFamily="34" charset="-120"/>
+                          <a:latin typeface="Calibri" pitchFamily="34" charset="0"/>
+                          <a:ea typeface="Calibri" pitchFamily="34" charset="-122"/>
+                          <a:cs typeface="Calibri" pitchFamily="34" charset="-120"/>
                         </a:rPr>
                         <a:t>Vision Board &amp; Goal Tracking</a:t>
                       </a:r>
                       <a:endParaRPr lang="en-US" sz="1100" dirty="0">
-                        <a:latin typeface="Carlito" charset="0"/>
-                        <a:ea typeface="Carlito" charset="0"/>
-                        <a:cs typeface="Carlito" charset="0"/>
+                        <a:latin typeface="Calibri" charset="0"/>
+                        <a:ea typeface="Calibri" charset="0"/>
+                        <a:cs typeface="Calibri" charset="0"/>
                       </a:endParaRPr>
                     </a:p>
                   </a:txBody>
@@ -10767,16 +10767,16 @@
                           <a:solidFill>
                             <a:srgbClr val="00C853"/>
                           </a:solidFill>
-                          <a:latin typeface="Carlito" pitchFamily="34" charset="0"/>
-                          <a:ea typeface="Carlito" pitchFamily="34" charset="-122"/>
-                          <a:cs typeface="Carlito" pitchFamily="34" charset="-120"/>
+                          <a:latin typeface="Calibri" pitchFamily="34" charset="0"/>
+                          <a:ea typeface="Calibri" pitchFamily="34" charset="-122"/>
+                          <a:cs typeface="Calibri" pitchFamily="34" charset="-120"/>
                         </a:rPr>
                         <a:t>YES</a:t>
                       </a:r>
                       <a:endParaRPr lang="en-US" sz="1100" dirty="0">
-                        <a:latin typeface="Carlito" charset="0"/>
-                        <a:ea typeface="Carlito" charset="0"/>
-                        <a:cs typeface="Carlito" charset="0"/>
+                        <a:latin typeface="Calibri" charset="0"/>
+                        <a:ea typeface="Calibri" charset="0"/>
+                        <a:cs typeface="Calibri" charset="0"/>
                       </a:endParaRPr>
                     </a:p>
                   </a:txBody>
@@ -10835,16 +10835,16 @@
                           <a:solidFill>
                             <a:srgbClr val="888888"/>
                           </a:solidFill>
-                          <a:latin typeface="Carlito" pitchFamily="34" charset="0"/>
-                          <a:ea typeface="Carlito" pitchFamily="34" charset="-122"/>
-                          <a:cs typeface="Carlito" pitchFamily="34" charset="-120"/>
+                          <a:latin typeface="Calibri" pitchFamily="34" charset="0"/>
+                          <a:ea typeface="Calibri" pitchFamily="34" charset="-122"/>
+                          <a:cs typeface="Calibri" pitchFamily="34" charset="-120"/>
                         </a:rPr>
                         <a:t>No</a:t>
                       </a:r>
                       <a:endParaRPr lang="en-US" sz="1100" dirty="0">
-                        <a:latin typeface="Carlito" charset="0"/>
-                        <a:ea typeface="Carlito" charset="0"/>
-                        <a:cs typeface="Carlito" charset="0"/>
+                        <a:latin typeface="Calibri" charset="0"/>
+                        <a:ea typeface="Calibri" charset="0"/>
+                        <a:cs typeface="Calibri" charset="0"/>
                       </a:endParaRPr>
                     </a:p>
                   </a:txBody>
@@ -10903,16 +10903,16 @@
                           <a:solidFill>
                             <a:srgbClr val="888888"/>
                           </a:solidFill>
-                          <a:latin typeface="Carlito" pitchFamily="34" charset="0"/>
-                          <a:ea typeface="Carlito" pitchFamily="34" charset="-122"/>
-                          <a:cs typeface="Carlito" pitchFamily="34" charset="-120"/>
+                          <a:latin typeface="Calibri" pitchFamily="34" charset="0"/>
+                          <a:ea typeface="Calibri" pitchFamily="34" charset="-122"/>
+                          <a:cs typeface="Calibri" pitchFamily="34" charset="-120"/>
                         </a:rPr>
                         <a:t>No</a:t>
                       </a:r>
                       <a:endParaRPr lang="en-US" sz="1100" dirty="0">
-                        <a:latin typeface="Carlito" charset="0"/>
-                        <a:ea typeface="Carlito" charset="0"/>
-                        <a:cs typeface="Carlito" charset="0"/>
+                        <a:latin typeface="Calibri" charset="0"/>
+                        <a:ea typeface="Calibri" charset="0"/>
+                        <a:cs typeface="Calibri" charset="0"/>
                       </a:endParaRPr>
                     </a:p>
                   </a:txBody>
@@ -10971,16 +10971,16 @@
                           <a:solidFill>
                             <a:srgbClr val="888888"/>
                           </a:solidFill>
-                          <a:latin typeface="Carlito" pitchFamily="34" charset="0"/>
-                          <a:ea typeface="Carlito" pitchFamily="34" charset="-122"/>
-                          <a:cs typeface="Carlito" pitchFamily="34" charset="-120"/>
+                          <a:latin typeface="Calibri" pitchFamily="34" charset="0"/>
+                          <a:ea typeface="Calibri" pitchFamily="34" charset="-122"/>
+                          <a:cs typeface="Calibri" pitchFamily="34" charset="-120"/>
                         </a:rPr>
                         <a:t>No</a:t>
                       </a:r>
                       <a:endParaRPr lang="en-US" sz="1100" dirty="0">
-                        <a:latin typeface="Carlito" charset="0"/>
-                        <a:ea typeface="Carlito" charset="0"/>
-                        <a:cs typeface="Carlito" charset="0"/>
+                        <a:latin typeface="Calibri" charset="0"/>
+                        <a:ea typeface="Calibri" charset="0"/>
+                        <a:cs typeface="Calibri" charset="0"/>
                       </a:endParaRPr>
                     </a:p>
                   </a:txBody>
@@ -11041,16 +11041,16 @@
                           <a:solidFill>
                             <a:srgbClr val="888888"/>
                           </a:solidFill>
-                          <a:latin typeface="Carlito" pitchFamily="34" charset="0"/>
-                          <a:ea typeface="Carlito" pitchFamily="34" charset="-122"/>
-                          <a:cs typeface="Carlito" pitchFamily="34" charset="-120"/>
+                          <a:latin typeface="Calibri" pitchFamily="34" charset="0"/>
+                          <a:ea typeface="Calibri" pitchFamily="34" charset="-122"/>
+                          <a:cs typeface="Calibri" pitchFamily="34" charset="-120"/>
                         </a:rPr>
                         <a:t>Personalized Smart Notifications</a:t>
                       </a:r>
                       <a:endParaRPr lang="en-US" sz="1100" dirty="0">
-                        <a:latin typeface="Carlito" charset="0"/>
-                        <a:ea typeface="Carlito" charset="0"/>
-                        <a:cs typeface="Carlito" charset="0"/>
+                        <a:latin typeface="Calibri" charset="0"/>
+                        <a:ea typeface="Calibri" charset="0"/>
+                        <a:cs typeface="Calibri" charset="0"/>
                       </a:endParaRPr>
                     </a:p>
                   </a:txBody>
@@ -11109,16 +11109,16 @@
                           <a:solidFill>
                             <a:srgbClr val="00C853"/>
                           </a:solidFill>
-                          <a:latin typeface="Carlito" pitchFamily="34" charset="0"/>
-                          <a:ea typeface="Carlito" pitchFamily="34" charset="-122"/>
-                          <a:cs typeface="Carlito" pitchFamily="34" charset="-120"/>
+                          <a:latin typeface="Calibri" pitchFamily="34" charset="0"/>
+                          <a:ea typeface="Calibri" pitchFamily="34" charset="-122"/>
+                          <a:cs typeface="Calibri" pitchFamily="34" charset="-120"/>
                         </a:rPr>
                         <a:t>YES</a:t>
                       </a:r>
                       <a:endParaRPr lang="en-US" sz="1100" dirty="0">
-                        <a:latin typeface="Carlito" charset="0"/>
-                        <a:ea typeface="Carlito" charset="0"/>
-                        <a:cs typeface="Carlito" charset="0"/>
+                        <a:latin typeface="Calibri" charset="0"/>
+                        <a:ea typeface="Calibri" charset="0"/>
+                        <a:cs typeface="Calibri" charset="0"/>
                       </a:endParaRPr>
                     </a:p>
                   </a:txBody>
@@ -11177,16 +11177,16 @@
                           <a:solidFill>
                             <a:srgbClr val="888888"/>
                           </a:solidFill>
-                          <a:latin typeface="Carlito" pitchFamily="34" charset="0"/>
-                          <a:ea typeface="Carlito" pitchFamily="34" charset="-122"/>
-                          <a:cs typeface="Carlito" pitchFamily="34" charset="-120"/>
+                          <a:latin typeface="Calibri" pitchFamily="34" charset="0"/>
+                          <a:ea typeface="Calibri" pitchFamily="34" charset="-122"/>
+                          <a:cs typeface="Calibri" pitchFamily="34" charset="-120"/>
                         </a:rPr>
                         <a:t>Generic</a:t>
                       </a:r>
                       <a:endParaRPr lang="en-US" sz="1100" dirty="0">
-                        <a:latin typeface="Carlito" charset="0"/>
-                        <a:ea typeface="Carlito" charset="0"/>
-                        <a:cs typeface="Carlito" charset="0"/>
+                        <a:latin typeface="Calibri" charset="0"/>
+                        <a:ea typeface="Calibri" charset="0"/>
+                        <a:cs typeface="Calibri" charset="0"/>
                       </a:endParaRPr>
                     </a:p>
                   </a:txBody>
@@ -11245,16 +11245,16 @@
                           <a:solidFill>
                             <a:srgbClr val="888888"/>
                           </a:solidFill>
-                          <a:latin typeface="Carlito" pitchFamily="34" charset="0"/>
-                          <a:ea typeface="Carlito" pitchFamily="34" charset="-122"/>
-                          <a:cs typeface="Carlito" pitchFamily="34" charset="-120"/>
+                          <a:latin typeface="Calibri" pitchFamily="34" charset="0"/>
+                          <a:ea typeface="Calibri" pitchFamily="34" charset="-122"/>
+                          <a:cs typeface="Calibri" pitchFamily="34" charset="-120"/>
                         </a:rPr>
                         <a:t>Generic</a:t>
                       </a:r>
                       <a:endParaRPr lang="en-US" sz="1100" dirty="0">
-                        <a:latin typeface="Carlito" charset="0"/>
-                        <a:ea typeface="Carlito" charset="0"/>
-                        <a:cs typeface="Carlito" charset="0"/>
+                        <a:latin typeface="Calibri" charset="0"/>
+                        <a:ea typeface="Calibri" charset="0"/>
+                        <a:cs typeface="Calibri" charset="0"/>
                       </a:endParaRPr>
                     </a:p>
                   </a:txBody>
@@ -11313,16 +11313,16 @@
                           <a:solidFill>
                             <a:srgbClr val="888888"/>
                           </a:solidFill>
-                          <a:latin typeface="Carlito" pitchFamily="34" charset="0"/>
-                          <a:ea typeface="Carlito" pitchFamily="34" charset="-122"/>
-                          <a:cs typeface="Carlito" pitchFamily="34" charset="-120"/>
+                          <a:latin typeface="Calibri" pitchFamily="34" charset="0"/>
+                          <a:ea typeface="Calibri" pitchFamily="34" charset="-122"/>
+                          <a:cs typeface="Calibri" pitchFamily="34" charset="-120"/>
                         </a:rPr>
                         <a:t>Generic</a:t>
                       </a:r>
                       <a:endParaRPr lang="en-US" sz="1100" dirty="0">
-                        <a:latin typeface="Carlito" charset="0"/>
-                        <a:ea typeface="Carlito" charset="0"/>
-                        <a:cs typeface="Carlito" charset="0"/>
+                        <a:latin typeface="Calibri" charset="0"/>
+                        <a:ea typeface="Calibri" charset="0"/>
+                        <a:cs typeface="Calibri" charset="0"/>
                       </a:endParaRPr>
                     </a:p>
                   </a:txBody>
@@ -11383,16 +11383,16 @@
                           <a:solidFill>
                             <a:srgbClr val="888888"/>
                           </a:solidFill>
-                          <a:latin typeface="Carlito" pitchFamily="34" charset="0"/>
-                          <a:ea typeface="Carlito" pitchFamily="34" charset="-122"/>
-                          <a:cs typeface="Carlito" pitchFamily="34" charset="-120"/>
+                          <a:latin typeface="Calibri" pitchFamily="34" charset="0"/>
+                          <a:ea typeface="Calibri" pitchFamily="34" charset="-122"/>
+                          <a:cs typeface="Calibri" pitchFamily="34" charset="-120"/>
                         </a:rPr>
                         <a:t>Price (Monthly)</a:t>
                       </a:r>
                       <a:endParaRPr lang="en-US" sz="1100" dirty="0">
-                        <a:latin typeface="Carlito" charset="0"/>
-                        <a:ea typeface="Carlito" charset="0"/>
-                        <a:cs typeface="Carlito" charset="0"/>
+                        <a:latin typeface="Calibri" charset="0"/>
+                        <a:ea typeface="Calibri" charset="0"/>
+                        <a:cs typeface="Calibri" charset="0"/>
                       </a:endParaRPr>
                     </a:p>
                   </a:txBody>
@@ -11451,16 +11451,16 @@
                           <a:solidFill>
                             <a:srgbClr val="00D4FF"/>
                           </a:solidFill>
-                          <a:latin typeface="Carlito" pitchFamily="34" charset="0"/>
-                          <a:ea typeface="Carlito" pitchFamily="34" charset="-122"/>
-                          <a:cs typeface="Carlito" pitchFamily="34" charset="-120"/>
+                          <a:latin typeface="Calibri" pitchFamily="34" charset="0"/>
+                          <a:ea typeface="Calibri" pitchFamily="34" charset="-122"/>
+                          <a:cs typeface="Calibri" pitchFamily="34" charset="-120"/>
                         </a:rPr>
                         <a:t>$9.99</a:t>
                       </a:r>
                       <a:endParaRPr lang="en-US" sz="1100" dirty="0">
-                        <a:latin typeface="Carlito" charset="0"/>
-                        <a:ea typeface="Carlito" charset="0"/>
-                        <a:cs typeface="Carlito" charset="0"/>
+                        <a:latin typeface="Calibri" charset="0"/>
+                        <a:ea typeface="Calibri" charset="0"/>
+                        <a:cs typeface="Calibri" charset="0"/>
                       </a:endParaRPr>
                     </a:p>
                   </a:txBody>
@@ -11519,16 +11519,16 @@
                           <a:solidFill>
                             <a:srgbClr val="888888"/>
                           </a:solidFill>
-                          <a:latin typeface="Carlito" pitchFamily="34" charset="0"/>
-                          <a:ea typeface="Carlito" pitchFamily="34" charset="-122"/>
-                          <a:cs typeface="Carlito" pitchFamily="34" charset="-120"/>
+                          <a:latin typeface="Calibri" pitchFamily="34" charset="0"/>
+                          <a:ea typeface="Calibri" pitchFamily="34" charset="-122"/>
+                          <a:cs typeface="Calibri" pitchFamily="34" charset="-120"/>
                         </a:rPr>
                         <a:t>$12.99</a:t>
                       </a:r>
                       <a:endParaRPr lang="en-US" sz="1100" dirty="0">
-                        <a:latin typeface="Carlito" charset="0"/>
-                        <a:ea typeface="Carlito" charset="0"/>
-                        <a:cs typeface="Carlito" charset="0"/>
+                        <a:latin typeface="Calibri" charset="0"/>
+                        <a:ea typeface="Calibri" charset="0"/>
+                        <a:cs typeface="Calibri" charset="0"/>
                       </a:endParaRPr>
                     </a:p>
                   </a:txBody>
@@ -11587,16 +11587,16 @@
                           <a:solidFill>
                             <a:srgbClr val="888888"/>
                           </a:solidFill>
-                          <a:latin typeface="Carlito" pitchFamily="34" charset="0"/>
-                          <a:ea typeface="Carlito" pitchFamily="34" charset="-122"/>
-                          <a:cs typeface="Carlito" pitchFamily="34" charset="-120"/>
+                          <a:latin typeface="Calibri" pitchFamily="34" charset="0"/>
+                          <a:ea typeface="Calibri" pitchFamily="34" charset="-122"/>
+                          <a:cs typeface="Calibri" pitchFamily="34" charset="-120"/>
                         </a:rPr>
                         <a:t>$80+</a:t>
                       </a:r>
                       <a:endParaRPr lang="en-US" sz="1100" dirty="0">
-                        <a:latin typeface="Carlito" charset="0"/>
-                        <a:ea typeface="Carlito" charset="0"/>
-                        <a:cs typeface="Carlito" charset="0"/>
+                        <a:latin typeface="Calibri" charset="0"/>
+                        <a:ea typeface="Calibri" charset="0"/>
+                        <a:cs typeface="Calibri" charset="0"/>
                       </a:endParaRPr>
                     </a:p>
                   </a:txBody>
@@ -11655,16 +11655,16 @@
                           <a:solidFill>
                             <a:srgbClr val="888888"/>
                           </a:solidFill>
-                          <a:latin typeface="Carlito" pitchFamily="34" charset="0"/>
-                          <a:ea typeface="Carlito" pitchFamily="34" charset="-122"/>
-                          <a:cs typeface="Carlito" pitchFamily="34" charset="-120"/>
+                          <a:latin typeface="Calibri" pitchFamily="34" charset="0"/>
+                          <a:ea typeface="Calibri" pitchFamily="34" charset="-122"/>
+                          <a:cs typeface="Calibri" pitchFamily="34" charset="-120"/>
                         </a:rPr>
                         <a:t>$14.99</a:t>
                       </a:r>
                       <a:endParaRPr lang="en-US" sz="1100" dirty="0">
-                        <a:latin typeface="Carlito" charset="0"/>
-                        <a:ea typeface="Carlito" charset="0"/>
-                        <a:cs typeface="Carlito" charset="0"/>
+                        <a:latin typeface="Calibri" charset="0"/>
+                        <a:ea typeface="Calibri" charset="0"/>
+                        <a:cs typeface="Calibri" charset="0"/>
                       </a:endParaRPr>
                     </a:p>
                   </a:txBody>
@@ -11744,9 +11744,9 @@
                 <a:solidFill>
                   <a:srgbClr val="D4A017"/>
                 </a:solidFill>
-                <a:latin typeface="Carlito" pitchFamily="34" charset="0"/>
-                <a:ea typeface="Carlito" pitchFamily="34" charset="-122"/>
-                <a:cs typeface="Carlito" pitchFamily="34" charset="-120"/>
+                <a:latin typeface="Calibri" pitchFamily="34" charset="0"/>
+                <a:ea typeface="Calibri" pitchFamily="34" charset="-122"/>
+                <a:cs typeface="Calibri" pitchFamily="34" charset="-120"/>
               </a:rPr>
               <a:t>Top Performer doesn't compete with meditation apps. It REPLACES your need for a $200/hr performance coach.</a:t>
             </a:r>
@@ -11835,9 +11835,9 @@
                 <a:solidFill>
                   <a:srgbClr val="00C853"/>
                 </a:solidFill>
-                <a:latin typeface="Carlito" pitchFamily="34" charset="0"/>
-                <a:ea typeface="Carlito" pitchFamily="34" charset="-122"/>
-                <a:cs typeface="Carlito" pitchFamily="34" charset="-120"/>
+                <a:latin typeface="Calibri" pitchFamily="34" charset="0"/>
+                <a:ea typeface="Calibri" pitchFamily="34" charset="-122"/>
+                <a:cs typeface="Calibri" pitchFamily="34" charset="-120"/>
               </a:rPr>
               <a:t>REVENUE MODEL</a:t>
             </a:r>
@@ -11874,9 +11874,9 @@
                 <a:solidFill>
                   <a:srgbClr val="FFFFFF"/>
                 </a:solidFill>
-                <a:latin typeface="Liberation Sans" pitchFamily="34" charset="0"/>
-                <a:ea typeface="Liberation Sans" pitchFamily="34" charset="-122"/>
-                <a:cs typeface="Liberation Sans" pitchFamily="34" charset="-120"/>
+                <a:latin typeface="Arial Black" pitchFamily="34" charset="0"/>
+                <a:ea typeface="Arial Black" pitchFamily="34" charset="-122"/>
+                <a:cs typeface="Arial Black" pitchFamily="34" charset="-120"/>
               </a:rPr>
               <a:t>Multiple Revenue Streams Built In</a:t>
             </a:r>
@@ -11984,9 +11984,9 @@
                 <a:solidFill>
                   <a:srgbClr val="FFFFFF"/>
                 </a:solidFill>
-                <a:latin typeface="Carlito" pitchFamily="34" charset="0"/>
-                <a:ea typeface="Carlito" pitchFamily="34" charset="-122"/>
-                <a:cs typeface="Carlito" pitchFamily="34" charset="-120"/>
+                <a:latin typeface="Calibri" pitchFamily="34" charset="0"/>
+                <a:ea typeface="Calibri" pitchFamily="34" charset="-122"/>
+                <a:cs typeface="Calibri" pitchFamily="34" charset="-120"/>
               </a:rPr>
               <a:t>Premium Subscription</a:t>
             </a:r>
@@ -12023,9 +12023,9 @@
                 <a:solidFill>
                   <a:srgbClr val="FFD700"/>
                 </a:solidFill>
-                <a:latin typeface="Carlito" pitchFamily="34" charset="0"/>
-                <a:ea typeface="Carlito" pitchFamily="34" charset="-122"/>
-                <a:cs typeface="Carlito" pitchFamily="34" charset="-120"/>
+                <a:latin typeface="Calibri" pitchFamily="34" charset="0"/>
+                <a:ea typeface="Calibri" pitchFamily="34" charset="-122"/>
+                <a:cs typeface="Calibri" pitchFamily="34" charset="-120"/>
               </a:rPr>
               <a:t>Primary Revenue</a:t>
             </a:r>
@@ -12062,9 +12062,9 @@
                 <a:solidFill>
                   <a:srgbClr val="888888"/>
                 </a:solidFill>
-                <a:latin typeface="Carlito" pitchFamily="34" charset="0"/>
-                <a:ea typeface="Carlito" pitchFamily="34" charset="-122"/>
-                <a:cs typeface="Carlito" pitchFamily="34" charset="-120"/>
+                <a:latin typeface="Calibri" pitchFamily="34" charset="0"/>
+                <a:ea typeface="Calibri" pitchFamily="34" charset="-122"/>
+                <a:cs typeface="Calibri" pitchFamily="34" charset="-120"/>
               </a:rPr>
               <a:t>$9.99/mo or $79.99/yr</a:t>
             </a:r>
@@ -12079,9 +12079,9 @@
                 <a:solidFill>
                   <a:srgbClr val="888888"/>
                 </a:solidFill>
-                <a:latin typeface="Carlito" pitchFamily="34" charset="0"/>
-                <a:ea typeface="Carlito" pitchFamily="34" charset="-122"/>
-                <a:cs typeface="Carlito" pitchFamily="34" charset="-120"/>
+                <a:latin typeface="Calibri" pitchFamily="34" charset="0"/>
+                <a:ea typeface="Calibri" pitchFamily="34" charset="-122"/>
+                <a:cs typeface="Calibri" pitchFamily="34" charset="-120"/>
               </a:rPr>
               <a:t>Unlimited AI coaching, advanced analytics,</a:t>
             </a:r>
@@ -12096,9 +12096,9 @@
                 <a:solidFill>
                   <a:srgbClr val="888888"/>
                 </a:solidFill>
-                <a:latin typeface="Carlito" pitchFamily="34" charset="0"/>
-                <a:ea typeface="Carlito" pitchFamily="34" charset="-122"/>
-                <a:cs typeface="Carlito" pitchFamily="34" charset="-120"/>
+                <a:latin typeface="Calibri" pitchFamily="34" charset="0"/>
+                <a:ea typeface="Calibri" pitchFamily="34" charset="-122"/>
+                <a:cs typeface="Calibri" pitchFamily="34" charset="-120"/>
               </a:rPr>
               <a:t>premium challenges, priority support</a:t>
             </a:r>
@@ -12206,9 +12206,9 @@
                 <a:solidFill>
                   <a:srgbClr val="FFFFFF"/>
                 </a:solidFill>
-                <a:latin typeface="Carlito" pitchFamily="34" charset="0"/>
-                <a:ea typeface="Carlito" pitchFamily="34" charset="-122"/>
-                <a:cs typeface="Carlito" pitchFamily="34" charset="-120"/>
+                <a:latin typeface="Calibri" pitchFamily="34" charset="0"/>
+                <a:ea typeface="Calibri" pitchFamily="34" charset="-122"/>
+                <a:cs typeface="Calibri" pitchFamily="34" charset="-120"/>
               </a:rPr>
               <a:t>Referral Engine</a:t>
             </a:r>
@@ -12245,9 +12245,9 @@
                 <a:solidFill>
                   <a:srgbClr val="00D4FF"/>
                 </a:solidFill>
-                <a:latin typeface="Carlito" pitchFamily="34" charset="0"/>
-                <a:ea typeface="Carlito" pitchFamily="34" charset="-122"/>
-                <a:cs typeface="Carlito" pitchFamily="34" charset="-120"/>
+                <a:latin typeface="Calibri" pitchFamily="34" charset="0"/>
+                <a:ea typeface="Calibri" pitchFamily="34" charset="-122"/>
+                <a:cs typeface="Calibri" pitchFamily="34" charset="-120"/>
               </a:rPr>
               <a:t>Viral Growth</a:t>
             </a:r>
@@ -12284,9 +12284,9 @@
                 <a:solidFill>
                   <a:srgbClr val="888888"/>
                 </a:solidFill>
-                <a:latin typeface="Carlito" pitchFamily="34" charset="0"/>
-                <a:ea typeface="Carlito" pitchFamily="34" charset="-122"/>
-                <a:cs typeface="Carlito" pitchFamily="34" charset="-120"/>
+                <a:latin typeface="Calibri" pitchFamily="34" charset="0"/>
+                <a:ea typeface="Calibri" pitchFamily="34" charset="-122"/>
+                <a:cs typeface="Calibri" pitchFamily="34" charset="-120"/>
               </a:rPr>
               <a:t>Built-in viral referral system</a:t>
             </a:r>
@@ -12301,9 +12301,9 @@
                 <a:solidFill>
                   <a:srgbClr val="888888"/>
                 </a:solidFill>
-                <a:latin typeface="Carlito" pitchFamily="34" charset="0"/>
-                <a:ea typeface="Carlito" pitchFamily="34" charset="-122"/>
-                <a:cs typeface="Carlito" pitchFamily="34" charset="-120"/>
+                <a:latin typeface="Calibri" pitchFamily="34" charset="0"/>
+                <a:ea typeface="Calibri" pitchFamily="34" charset="-122"/>
+                <a:cs typeface="Calibri" pitchFamily="34" charset="-120"/>
               </a:rPr>
               <a:t>100pts referrer + 50pts referred</a:t>
             </a:r>
@@ -12318,9 +12318,9 @@
                 <a:solidFill>
                   <a:srgbClr val="888888"/>
                 </a:solidFill>
-                <a:latin typeface="Carlito" pitchFamily="34" charset="0"/>
-                <a:ea typeface="Carlito" pitchFamily="34" charset="-122"/>
-                <a:cs typeface="Carlito" pitchFamily="34" charset="-120"/>
+                <a:latin typeface="Calibri" pitchFamily="34" charset="0"/>
+                <a:ea typeface="Calibri" pitchFamily="34" charset="-122"/>
+                <a:cs typeface="Calibri" pitchFamily="34" charset="-120"/>
               </a:rPr>
               <a:t>Leaderboard gamification drives organic growth</a:t>
             </a:r>
@@ -12428,9 +12428,9 @@
                 <a:solidFill>
                   <a:srgbClr val="FFFFFF"/>
                 </a:solidFill>
-                <a:latin typeface="Carlito" pitchFamily="34" charset="0"/>
-                <a:ea typeface="Carlito" pitchFamily="34" charset="-122"/>
-                <a:cs typeface="Carlito" pitchFamily="34" charset="-120"/>
+                <a:latin typeface="Calibri" pitchFamily="34" charset="0"/>
+                <a:ea typeface="Calibri" pitchFamily="34" charset="-122"/>
+                <a:cs typeface="Calibri" pitchFamily="34" charset="-120"/>
               </a:rPr>
               <a:t>Enterprise / B2B</a:t>
             </a:r>
@@ -12467,9 +12467,9 @@
                 <a:solidFill>
                   <a:srgbClr val="00C853"/>
                 </a:solidFill>
-                <a:latin typeface="Carlito" pitchFamily="34" charset="0"/>
-                <a:ea typeface="Carlito" pitchFamily="34" charset="-122"/>
-                <a:cs typeface="Carlito" pitchFamily="34" charset="-120"/>
+                <a:latin typeface="Calibri" pitchFamily="34" charset="0"/>
+                <a:ea typeface="Calibri" pitchFamily="34" charset="-122"/>
+                <a:cs typeface="Calibri" pitchFamily="34" charset="-120"/>
               </a:rPr>
               <a:t>Enterprise Upsell</a:t>
             </a:r>
@@ -12506,9 +12506,9 @@
                 <a:solidFill>
                   <a:srgbClr val="888888"/>
                 </a:solidFill>
-                <a:latin typeface="Carlito" pitchFamily="34" charset="0"/>
-                <a:ea typeface="Carlito" pitchFamily="34" charset="-122"/>
-                <a:cs typeface="Carlito" pitchFamily="34" charset="-120"/>
+                <a:latin typeface="Calibri" pitchFamily="34" charset="0"/>
+                <a:ea typeface="Calibri" pitchFamily="34" charset="-122"/>
+                <a:cs typeface="Calibri" pitchFamily="34" charset="-120"/>
               </a:rPr>
               <a:t>Employer wellness packages</a:t>
             </a:r>
@@ -12523,9 +12523,9 @@
                 <a:solidFill>
                   <a:srgbClr val="888888"/>
                 </a:solidFill>
-                <a:latin typeface="Carlito" pitchFamily="34" charset="0"/>
-                <a:ea typeface="Carlito" pitchFamily="34" charset="-122"/>
-                <a:cs typeface="Carlito" pitchFamily="34" charset="-120"/>
+                <a:latin typeface="Calibri" pitchFamily="34" charset="0"/>
+                <a:ea typeface="Calibri" pitchFamily="34" charset="-122"/>
+                <a:cs typeface="Calibri" pitchFamily="34" charset="-120"/>
               </a:rPr>
               <a:t>Team performance dashboards</a:t>
             </a:r>
@@ -12540,9 +12540,9 @@
                 <a:solidFill>
                   <a:srgbClr val="888888"/>
                 </a:solidFill>
-                <a:latin typeface="Carlito" pitchFamily="34" charset="0"/>
-                <a:ea typeface="Carlito" pitchFamily="34" charset="-122"/>
-                <a:cs typeface="Carlito" pitchFamily="34" charset="-120"/>
+                <a:latin typeface="Calibri" pitchFamily="34" charset="0"/>
+                <a:ea typeface="Calibri" pitchFamily="34" charset="-122"/>
+                <a:cs typeface="Calibri" pitchFamily="34" charset="-120"/>
               </a:rPr>
               <a:t>Bulk licensing for organizations</a:t>
             </a:r>
@@ -12650,9 +12650,9 @@
                 <a:solidFill>
                   <a:srgbClr val="FFFFFF"/>
                 </a:solidFill>
-                <a:latin typeface="Carlito" pitchFamily="34" charset="0"/>
-                <a:ea typeface="Carlito" pitchFamily="34" charset="-122"/>
-                <a:cs typeface="Carlito" pitchFamily="34" charset="-120"/>
+                <a:latin typeface="Calibri" pitchFamily="34" charset="0"/>
+                <a:ea typeface="Calibri" pitchFamily="34" charset="-122"/>
+                <a:cs typeface="Calibri" pitchFamily="34" charset="-120"/>
               </a:rPr>
               <a:t>Data Insights</a:t>
             </a:r>
@@ -12689,9 +12689,9 @@
                 <a:solidFill>
                   <a:srgbClr val="7C3AED"/>
                 </a:solidFill>
-                <a:latin typeface="Carlito" pitchFamily="34" charset="0"/>
-                <a:ea typeface="Carlito" pitchFamily="34" charset="-122"/>
-                <a:cs typeface="Carlito" pitchFamily="34" charset="-120"/>
+                <a:latin typeface="Calibri" pitchFamily="34" charset="0"/>
+                <a:ea typeface="Calibri" pitchFamily="34" charset="-122"/>
+                <a:cs typeface="Calibri" pitchFamily="34" charset="-120"/>
               </a:rPr>
               <a:t>Future Revenue</a:t>
             </a:r>
@@ -12728,9 +12728,9 @@
                 <a:solidFill>
                   <a:srgbClr val="888888"/>
                 </a:solidFill>
-                <a:latin typeface="Carlito" pitchFamily="34" charset="0"/>
-                <a:ea typeface="Carlito" pitchFamily="34" charset="-122"/>
-                <a:cs typeface="Carlito" pitchFamily="34" charset="-120"/>
+                <a:latin typeface="Calibri" pitchFamily="34" charset="0"/>
+                <a:ea typeface="Calibri" pitchFamily="34" charset="-122"/>
+                <a:cs typeface="Calibri" pitchFamily="34" charset="-120"/>
               </a:rPr>
               <a:t>Anonymized wellness trends</a:t>
             </a:r>
@@ -12745,9 +12745,9 @@
                 <a:solidFill>
                   <a:srgbClr val="888888"/>
                 </a:solidFill>
-                <a:latin typeface="Carlito" pitchFamily="34" charset="0"/>
-                <a:ea typeface="Carlito" pitchFamily="34" charset="-122"/>
-                <a:cs typeface="Carlito" pitchFamily="34" charset="-120"/>
+                <a:latin typeface="Calibri" pitchFamily="34" charset="0"/>
+                <a:ea typeface="Calibri" pitchFamily="34" charset="-122"/>
+                <a:cs typeface="Calibri" pitchFamily="34" charset="-120"/>
               </a:rPr>
               <a:t>Workplace mental health analytics</a:t>
             </a:r>
@@ -12762,9 +12762,9 @@
                 <a:solidFill>
                   <a:srgbClr val="888888"/>
                 </a:solidFill>
-                <a:latin typeface="Carlito" pitchFamily="34" charset="0"/>
-                <a:ea typeface="Carlito" pitchFamily="34" charset="-122"/>
-                <a:cs typeface="Carlito" pitchFamily="34" charset="-120"/>
+                <a:latin typeface="Calibri" pitchFamily="34" charset="0"/>
+                <a:ea typeface="Calibri" pitchFamily="34" charset="-122"/>
+                <a:cs typeface="Calibri" pitchFamily="34" charset="-120"/>
               </a:rPr>
               <a:t>Partnership opportunities</a:t>
             </a:r>
@@ -12853,9 +12853,9 @@
                 <a:solidFill>
                   <a:srgbClr val="00D4FF"/>
                 </a:solidFill>
-                <a:latin typeface="Carlito" pitchFamily="34" charset="0"/>
-                <a:ea typeface="Carlito" pitchFamily="34" charset="-122"/>
-                <a:cs typeface="Carlito" pitchFamily="34" charset="-120"/>
+                <a:latin typeface="Calibri" pitchFamily="34" charset="0"/>
+                <a:ea typeface="Calibri" pitchFamily="34" charset="-122"/>
+                <a:cs typeface="Calibri" pitchFamily="34" charset="-120"/>
               </a:rPr>
               <a:t>BUILT. SHIPPED. LIVE.</a:t>
             </a:r>
@@ -12892,9 +12892,9 @@
                 <a:solidFill>
                   <a:srgbClr val="FFFFFF"/>
                 </a:solidFill>
-                <a:latin typeface="Liberation Sans" pitchFamily="34" charset="0"/>
-                <a:ea typeface="Liberation Sans" pitchFamily="34" charset="-122"/>
-                <a:cs typeface="Liberation Sans" pitchFamily="34" charset="-120"/>
+                <a:latin typeface="Arial Black" pitchFamily="34" charset="0"/>
+                <a:ea typeface="Arial Black" pitchFamily="34" charset="-122"/>
+                <a:cs typeface="Arial Black" pitchFamily="34" charset="-120"/>
               </a:rPr>
               <a:t>This Isn't a Mockup. It's LIVE.</a:t>
             </a:r>
@@ -12958,9 +12958,9 @@
                 <a:solidFill>
                   <a:srgbClr val="00D4FF"/>
                 </a:solidFill>
-                <a:latin typeface="Liberation Sans" pitchFamily="34" charset="0"/>
-                <a:ea typeface="Liberation Sans" pitchFamily="34" charset="-122"/>
-                <a:cs typeface="Liberation Sans" pitchFamily="34" charset="-120"/>
+                <a:latin typeface="Arial Black" pitchFamily="34" charset="0"/>
+                <a:ea typeface="Arial Black" pitchFamily="34" charset="-122"/>
+                <a:cs typeface="Arial Black" pitchFamily="34" charset="-120"/>
               </a:rPr>
               <a:t>150+</a:t>
             </a:r>
@@ -12997,9 +12997,9 @@
                 <a:solidFill>
                   <a:srgbClr val="888888"/>
                 </a:solidFill>
-                <a:latin typeface="Carlito" pitchFamily="34" charset="0"/>
-                <a:ea typeface="Carlito" pitchFamily="34" charset="-122"/>
-                <a:cs typeface="Carlito" pitchFamily="34" charset="-120"/>
+                <a:latin typeface="Calibri" pitchFamily="34" charset="0"/>
+                <a:ea typeface="Calibri" pitchFamily="34" charset="-122"/>
+                <a:cs typeface="Calibri" pitchFamily="34" charset="-120"/>
               </a:rPr>
               <a:t>API</a:t>
             </a:r>
@@ -13014,9 +13014,9 @@
                 <a:solidFill>
                   <a:srgbClr val="888888"/>
                 </a:solidFill>
-                <a:latin typeface="Carlito" pitchFamily="34" charset="0"/>
-                <a:ea typeface="Carlito" pitchFamily="34" charset="-122"/>
-                <a:cs typeface="Carlito" pitchFamily="34" charset="-120"/>
+                <a:latin typeface="Calibri" pitchFamily="34" charset="0"/>
+                <a:ea typeface="Calibri" pitchFamily="34" charset="-122"/>
+                <a:cs typeface="Calibri" pitchFamily="34" charset="-120"/>
               </a:rPr>
               <a:t>Endpoints</a:t>
             </a:r>
@@ -13080,9 +13080,9 @@
                 <a:solidFill>
                   <a:srgbClr val="00D4FF"/>
                 </a:solidFill>
-                <a:latin typeface="Liberation Sans" pitchFamily="34" charset="0"/>
-                <a:ea typeface="Liberation Sans" pitchFamily="34" charset="-122"/>
-                <a:cs typeface="Liberation Sans" pitchFamily="34" charset="-120"/>
+                <a:latin typeface="Arial Black" pitchFamily="34" charset="0"/>
+                <a:ea typeface="Arial Black" pitchFamily="34" charset="-122"/>
+                <a:cs typeface="Arial Black" pitchFamily="34" charset="-120"/>
               </a:rPr>
               <a:t>9</a:t>
             </a:r>
@@ -13119,9 +13119,9 @@
                 <a:solidFill>
                   <a:srgbClr val="888888"/>
                 </a:solidFill>
-                <a:latin typeface="Carlito" pitchFamily="34" charset="0"/>
-                <a:ea typeface="Carlito" pitchFamily="34" charset="-122"/>
-                <a:cs typeface="Carlito" pitchFamily="34" charset="-120"/>
+                <a:latin typeface="Calibri" pitchFamily="34" charset="0"/>
+                <a:ea typeface="Calibri" pitchFamily="34" charset="-122"/>
+                <a:cs typeface="Calibri" pitchFamily="34" charset="-120"/>
               </a:rPr>
               <a:t>Core</a:t>
             </a:r>
@@ -13136,9 +13136,9 @@
                 <a:solidFill>
                   <a:srgbClr val="888888"/>
                 </a:solidFill>
-                <a:latin typeface="Carlito" pitchFamily="34" charset="0"/>
-                <a:ea typeface="Carlito" pitchFamily="34" charset="-122"/>
-                <a:cs typeface="Carlito" pitchFamily="34" charset="-120"/>
+                <a:latin typeface="Calibri" pitchFamily="34" charset="0"/>
+                <a:ea typeface="Calibri" pitchFamily="34" charset="-122"/>
+                <a:cs typeface="Calibri" pitchFamily="34" charset="-120"/>
               </a:rPr>
               <a:t>Screens</a:t>
             </a:r>
@@ -13202,9 +13202,9 @@
                 <a:solidFill>
                   <a:srgbClr val="00D4FF"/>
                 </a:solidFill>
-                <a:latin typeface="Liberation Sans" pitchFamily="34" charset="0"/>
-                <a:ea typeface="Liberation Sans" pitchFamily="34" charset="-122"/>
-                <a:cs typeface="Liberation Sans" pitchFamily="34" charset="-120"/>
+                <a:latin typeface="Arial Black" pitchFamily="34" charset="0"/>
+                <a:ea typeface="Arial Black" pitchFamily="34" charset="-122"/>
+                <a:cs typeface="Arial Black" pitchFamily="34" charset="-120"/>
               </a:rPr>
               <a:t>14</a:t>
             </a:r>
@@ -13241,9 +13241,9 @@
                 <a:solidFill>
                   <a:srgbClr val="888888"/>
                 </a:solidFill>
-                <a:latin typeface="Carlito" pitchFamily="34" charset="0"/>
-                <a:ea typeface="Carlito" pitchFamily="34" charset="-122"/>
-                <a:cs typeface="Carlito" pitchFamily="34" charset="-120"/>
+                <a:latin typeface="Calibri" pitchFamily="34" charset="0"/>
+                <a:ea typeface="Calibri" pitchFamily="34" charset="-122"/>
+                <a:cs typeface="Calibri" pitchFamily="34" charset="-120"/>
               </a:rPr>
               <a:t>Database</a:t>
             </a:r>
@@ -13258,9 +13258,9 @@
                 <a:solidFill>
                   <a:srgbClr val="888888"/>
                 </a:solidFill>
-                <a:latin typeface="Carlito" pitchFamily="34" charset="0"/>
-                <a:ea typeface="Carlito" pitchFamily="34" charset="-122"/>
-                <a:cs typeface="Carlito" pitchFamily="34" charset="-120"/>
+                <a:latin typeface="Calibri" pitchFamily="34" charset="0"/>
+                <a:ea typeface="Calibri" pitchFamily="34" charset="-122"/>
+                <a:cs typeface="Calibri" pitchFamily="34" charset="-120"/>
               </a:rPr>
               <a:t>Tables</a:t>
             </a:r>
@@ -13324,9 +13324,9 @@
                 <a:solidFill>
                   <a:srgbClr val="00D4FF"/>
                 </a:solidFill>
-                <a:latin typeface="Liberation Sans" pitchFamily="34" charset="0"/>
-                <a:ea typeface="Liberation Sans" pitchFamily="34" charset="-122"/>
-                <a:cs typeface="Liberation Sans" pitchFamily="34" charset="-120"/>
+                <a:latin typeface="Arial Black" pitchFamily="34" charset="0"/>
+                <a:ea typeface="Arial Black" pitchFamily="34" charset="-122"/>
+                <a:cs typeface="Arial Black" pitchFamily="34" charset="-120"/>
               </a:rPr>
               <a:t>12</a:t>
             </a:r>
@@ -13363,9 +13363,9 @@
                 <a:solidFill>
                   <a:srgbClr val="888888"/>
                 </a:solidFill>
-                <a:latin typeface="Carlito" pitchFamily="34" charset="0"/>
-                <a:ea typeface="Carlito" pitchFamily="34" charset="-122"/>
-                <a:cs typeface="Carlito" pitchFamily="34" charset="-120"/>
+                <a:latin typeface="Calibri" pitchFamily="34" charset="0"/>
+                <a:ea typeface="Calibri" pitchFamily="34" charset="-122"/>
+                <a:cs typeface="Calibri" pitchFamily="34" charset="-120"/>
               </a:rPr>
               <a:t>Engineering</a:t>
             </a:r>
@@ -13380,9 +13380,9 @@
                 <a:solidFill>
                   <a:srgbClr val="888888"/>
                 </a:solidFill>
-                <a:latin typeface="Carlito" pitchFamily="34" charset="0"/>
-                <a:ea typeface="Carlito" pitchFamily="34" charset="-122"/>
-                <a:cs typeface="Carlito" pitchFamily="34" charset="-120"/>
+                <a:latin typeface="Calibri" pitchFamily="34" charset="0"/>
+                <a:ea typeface="Calibri" pitchFamily="34" charset="-122"/>
+                <a:cs typeface="Calibri" pitchFamily="34" charset="-120"/>
               </a:rPr>
               <a:t>Phases Complete</a:t>
             </a:r>
@@ -13420,9 +13420,9 @@
                 <a:solidFill>
                   <a:srgbClr val="CCCCCC"/>
                 </a:solidFill>
-                <a:latin typeface="Carlito" pitchFamily="34" charset="0"/>
-                <a:ea typeface="Carlito" pitchFamily="34" charset="-122"/>
-                <a:cs typeface="Carlito" pitchFamily="34" charset="-120"/>
+                <a:latin typeface="Calibri" pitchFamily="34" charset="0"/>
+                <a:ea typeface="Calibri" pitchFamily="34" charset="-122"/>
+                <a:cs typeface="Calibri" pitchFamily="34" charset="-120"/>
               </a:rPr>
               <a:t>React.js Progressive Web App (iOS + Android)</a:t>
             </a:r>
@@ -13460,9 +13460,9 @@
                 <a:solidFill>
                   <a:srgbClr val="CCCCCC"/>
                 </a:solidFill>
-                <a:latin typeface="Carlito" pitchFamily="34" charset="0"/>
-                <a:ea typeface="Carlito" pitchFamily="34" charset="-122"/>
-                <a:cs typeface="Carlito" pitchFamily="34" charset="-120"/>
+                <a:latin typeface="Calibri" pitchFamily="34" charset="0"/>
+                <a:ea typeface="Calibri" pitchFamily="34" charset="-122"/>
+                <a:cs typeface="Calibri" pitchFamily="34" charset="-120"/>
               </a:rPr>
               <a:t>Express.js + PostgreSQL backend on Render</a:t>
             </a:r>
@@ -13500,9 +13500,9 @@
                 <a:solidFill>
                   <a:srgbClr val="CCCCCC"/>
                 </a:solidFill>
-                <a:latin typeface="Carlito" pitchFamily="34" charset="0"/>
-                <a:ea typeface="Carlito" pitchFamily="34" charset="-122"/>
-                <a:cs typeface="Carlito" pitchFamily="34" charset="-120"/>
+                <a:latin typeface="Calibri" pitchFamily="34" charset="0"/>
+                <a:ea typeface="Calibri" pitchFamily="34" charset="-122"/>
+                <a:cs typeface="Calibri" pitchFamily="34" charset="-120"/>
               </a:rPr>
               <a:t>Claude AI (Anthropic) for conversational coaching</a:t>
             </a:r>
@@ -13540,9 +13540,9 @@
                 <a:solidFill>
                   <a:srgbClr val="CCCCCC"/>
                 </a:solidFill>
-                <a:latin typeface="Carlito" pitchFamily="34" charset="0"/>
-                <a:ea typeface="Carlito" pitchFamily="34" charset="-122"/>
-                <a:cs typeface="Carlito" pitchFamily="34" charset="-120"/>
+                <a:latin typeface="Calibri" pitchFamily="34" charset="0"/>
+                <a:ea typeface="Calibri" pitchFamily="34" charset="-122"/>
+                <a:cs typeface="Calibri" pitchFamily="34" charset="-120"/>
               </a:rPr>
               <a:t>Socket.IO real-time messaging</a:t>
             </a:r>
@@ -13580,9 +13580,9 @@
                 <a:solidFill>
                   <a:srgbClr val="CCCCCC"/>
                 </a:solidFill>
-                <a:latin typeface="Carlito" pitchFamily="34" charset="0"/>
-                <a:ea typeface="Carlito" pitchFamily="34" charset="-122"/>
-                <a:cs typeface="Carlito" pitchFamily="34" charset="-120"/>
+                <a:latin typeface="Calibri" pitchFamily="34" charset="0"/>
+                <a:ea typeface="Calibri" pitchFamily="34" charset="-122"/>
+                <a:cs typeface="Calibri" pitchFamily="34" charset="-120"/>
               </a:rPr>
               <a:t>Apple Push Notification Service (APNS)</a:t>
             </a:r>
@@ -13620,9 +13620,9 @@
                 <a:solidFill>
                   <a:srgbClr val="CCCCCC"/>
                 </a:solidFill>
-                <a:latin typeface="Carlito" pitchFamily="34" charset="0"/>
-                <a:ea typeface="Carlito" pitchFamily="34" charset="-122"/>
-                <a:cs typeface="Carlito" pitchFamily="34" charset="-120"/>
+                <a:latin typeface="Calibri" pitchFamily="34" charset="0"/>
+                <a:ea typeface="Calibri" pitchFamily="34" charset="-122"/>
+                <a:cs typeface="Calibri" pitchFamily="34" charset="-120"/>
               </a:rPr>
               <a:t>Sentry error monitoring + Mixpanel analytics</a:t>
             </a:r>
@@ -13660,9 +13660,9 @@
                 <a:solidFill>
                   <a:srgbClr val="CCCCCC"/>
                 </a:solidFill>
-                <a:latin typeface="Carlito" pitchFamily="34" charset="0"/>
-                <a:ea typeface="Carlito" pitchFamily="34" charset="-122"/>
-                <a:cs typeface="Carlito" pitchFamily="34" charset="-120"/>
+                <a:latin typeface="Calibri" pitchFamily="34" charset="0"/>
+                <a:ea typeface="Calibri" pitchFamily="34" charset="-122"/>
+                <a:cs typeface="Calibri" pitchFamily="34" charset="-120"/>
               </a:rPr>
               <a:t>Apple App Store ready (Bundle ID registered)</a:t>
             </a:r>
@@ -13700,9 +13700,9 @@
                 <a:solidFill>
                   <a:srgbClr val="CCCCCC"/>
                 </a:solidFill>
-                <a:latin typeface="Carlito" pitchFamily="34" charset="0"/>
-                <a:ea typeface="Carlito" pitchFamily="34" charset="-122"/>
-                <a:cs typeface="Carlito" pitchFamily="34" charset="-120"/>
+                <a:latin typeface="Calibri" pitchFamily="34" charset="0"/>
+                <a:ea typeface="Calibri" pitchFamily="34" charset="-122"/>
+                <a:cs typeface="Calibri" pitchFamily="34" charset="-120"/>
               </a:rPr>
               <a:t>RevenueCat subscription management</a:t>
             </a:r>
@@ -13740,9 +13740,9 @@
                 <a:solidFill>
                   <a:srgbClr val="CCCCCC"/>
                 </a:solidFill>
-                <a:latin typeface="Carlito" pitchFamily="34" charset="0"/>
-                <a:ea typeface="Carlito" pitchFamily="34" charset="-122"/>
-                <a:cs typeface="Carlito" pitchFamily="34" charset="-120"/>
+                <a:latin typeface="Calibri" pitchFamily="34" charset="0"/>
+                <a:ea typeface="Calibri" pitchFamily="34" charset="-122"/>
+                <a:cs typeface="Calibri" pitchFamily="34" charset="-120"/>
               </a:rPr>
               <a:t>Redis caching for performance</a:t>
             </a:r>
@@ -13780,9 +13780,9 @@
                 <a:solidFill>
                   <a:srgbClr val="CCCCCC"/>
                 </a:solidFill>
-                <a:latin typeface="Carlito" pitchFamily="34" charset="0"/>
-                <a:ea typeface="Carlito" pitchFamily="34" charset="-122"/>
-                <a:cs typeface="Carlito" pitchFamily="34" charset="-120"/>
+                <a:latin typeface="Calibri" pitchFamily="34" charset="0"/>
+                <a:ea typeface="Calibri" pitchFamily="34" charset="-122"/>
+                <a:cs typeface="Calibri" pitchFamily="34" charset="-120"/>
               </a:rPr>
               <a:t>End-to-end encryption for messages</a:t>
             </a:r>
@@ -13820,9 +13820,9 @@
                 <a:solidFill>
                   <a:srgbClr val="CCCCCC"/>
                 </a:solidFill>
-                <a:latin typeface="Carlito" pitchFamily="34" charset="0"/>
-                <a:ea typeface="Carlito" pitchFamily="34" charset="-122"/>
-                <a:cs typeface="Carlito" pitchFamily="34" charset="-120"/>
+                <a:latin typeface="Calibri" pitchFamily="34" charset="0"/>
+                <a:ea typeface="Calibri" pitchFamily="34" charset="-122"/>
+                <a:cs typeface="Calibri" pitchFamily="34" charset="-120"/>
               </a:rPr>
               <a:t>Automated email campaigns (SendGrid)</a:t>
             </a:r>
@@ -13860,9 +13860,9 @@
                 <a:solidFill>
                   <a:srgbClr val="CCCCCC"/>
                 </a:solidFill>
-                <a:latin typeface="Carlito" pitchFamily="34" charset="0"/>
-                <a:ea typeface="Carlito" pitchFamily="34" charset="-122"/>
-                <a:cs typeface="Carlito" pitchFamily="34" charset="-120"/>
+                <a:latin typeface="Calibri" pitchFamily="34" charset="0"/>
+                <a:ea typeface="Calibri" pitchFamily="34" charset="-122"/>
+                <a:cs typeface="Calibri" pitchFamily="34" charset="-120"/>
               </a:rPr>
               <a:t>Feature flags for staged rollouts</a:t>
             </a:r>
@@ -13899,9 +13899,9 @@
                 <a:solidFill>
                   <a:srgbClr val="D4A017"/>
                 </a:solidFill>
-                <a:latin typeface="Carlito" pitchFamily="34" charset="0"/>
-                <a:ea typeface="Carlito" pitchFamily="34" charset="-122"/>
-                <a:cs typeface="Carlito" pitchFamily="34" charset="-120"/>
+                <a:latin typeface="Calibri" pitchFamily="34" charset="0"/>
+                <a:ea typeface="Calibri" pitchFamily="34" charset="-122"/>
+                <a:cs typeface="Calibri" pitchFamily="34" charset="-120"/>
               </a:rPr>
               <a:t>Live now: mj-superstars-app.onrender.com</a:t>
             </a:r>
@@ -13990,9 +13990,9 @@
                 <a:solidFill>
                   <a:srgbClr val="D4A017"/>
                 </a:solidFill>
-                <a:latin typeface="Carlito" pitchFamily="34" charset="0"/>
-                <a:ea typeface="Carlito" pitchFamily="34" charset="-122"/>
-                <a:cs typeface="Carlito" pitchFamily="34" charset="-120"/>
+                <a:latin typeface="Calibri" pitchFamily="34" charset="0"/>
+                <a:ea typeface="Calibri" pitchFamily="34" charset="-122"/>
+                <a:cs typeface="Calibri" pitchFamily="34" charset="-120"/>
               </a:rPr>
               <a:t>BRAND STRATEGY</a:t>
             </a:r>
@@ -14029,9 +14029,9 @@
                 <a:solidFill>
                   <a:srgbClr val="FFFFFF"/>
                 </a:solidFill>
-                <a:latin typeface="Liberation Sans" pitchFamily="34" charset="0"/>
-                <a:ea typeface="Liberation Sans" pitchFamily="34" charset="-122"/>
-                <a:cs typeface="Liberation Sans" pitchFamily="34" charset="-120"/>
+                <a:latin typeface="Arial Black" pitchFamily="34" charset="0"/>
+                <a:ea typeface="Arial Black" pitchFamily="34" charset="-122"/>
+                <a:cs typeface="Arial Black" pitchFamily="34" charset="-120"/>
               </a:rPr>
               <a:t>Brand Identity + Logo Concepts</a:t>
             </a:r>
@@ -14095,9 +14095,9 @@
                 <a:solidFill>
                   <a:srgbClr val="888888"/>
                 </a:solidFill>
-                <a:latin typeface="Carlito" pitchFamily="34" charset="0"/>
-                <a:ea typeface="Carlito" pitchFamily="34" charset="-122"/>
-                <a:cs typeface="Carlito" pitchFamily="34" charset="-120"/>
+                <a:latin typeface="Calibri" pitchFamily="34" charset="0"/>
+                <a:ea typeface="Calibri" pitchFamily="34" charset="-122"/>
+                <a:cs typeface="Calibri" pitchFamily="34" charset="-120"/>
               </a:rPr>
               <a:t>Option A</a:t>
             </a:r>
@@ -14156,9 +14156,9 @@
                 <a:solidFill>
                   <a:srgbClr val="0A0A0A"/>
                 </a:solidFill>
-                <a:latin typeface="Liberation Sans" pitchFamily="34" charset="0"/>
-                <a:ea typeface="Liberation Sans" pitchFamily="34" charset="-122"/>
-                <a:cs typeface="Liberation Sans" pitchFamily="34" charset="-120"/>
+                <a:latin typeface="Arial Black" pitchFamily="34" charset="0"/>
+                <a:ea typeface="Arial Black" pitchFamily="34" charset="-122"/>
+                <a:cs typeface="Arial Black" pitchFamily="34" charset="-120"/>
               </a:rPr>
               <a:t>TP 1%</a:t>
             </a:r>
@@ -14195,9 +14195,9 @@
                 <a:solidFill>
                   <a:srgbClr val="CCCCCC"/>
                 </a:solidFill>
-                <a:latin typeface="Carlito" pitchFamily="34" charset="0"/>
-                <a:ea typeface="Carlito" pitchFamily="34" charset="-122"/>
-                <a:cs typeface="Carlito" pitchFamily="34" charset="-120"/>
+                <a:latin typeface="Calibri" pitchFamily="34" charset="0"/>
+                <a:ea typeface="Calibri" pitchFamily="34" charset="-122"/>
+                <a:cs typeface="Calibri" pitchFamily="34" charset="-120"/>
               </a:rPr>
               <a:t>Classic badge mark</a:t>
             </a:r>
@@ -14234,9 +14234,9 @@
                 <a:solidFill>
                   <a:srgbClr val="888888"/>
                 </a:solidFill>
-                <a:latin typeface="Carlito" pitchFamily="34" charset="0"/>
-                <a:ea typeface="Carlito" pitchFamily="34" charset="-122"/>
-                <a:cs typeface="Carlito" pitchFamily="34" charset="-120"/>
+                <a:latin typeface="Calibri" pitchFamily="34" charset="0"/>
+                <a:ea typeface="Calibri" pitchFamily="34" charset="-122"/>
+                <a:cs typeface="Calibri" pitchFamily="34" charset="-120"/>
               </a:rPr>
               <a:t>Compact. Iconic. Merch-ready.</a:t>
             </a:r>
@@ -14300,9 +14300,9 @@
                 <a:solidFill>
                   <a:srgbClr val="888888"/>
                 </a:solidFill>
-                <a:latin typeface="Carlito" pitchFamily="34" charset="0"/>
-                <a:ea typeface="Carlito" pitchFamily="34" charset="-122"/>
-                <a:cs typeface="Carlito" pitchFamily="34" charset="-120"/>
+                <a:latin typeface="Calibri" pitchFamily="34" charset="0"/>
+                <a:ea typeface="Calibri" pitchFamily="34" charset="-122"/>
+                <a:cs typeface="Calibri" pitchFamily="34" charset="-120"/>
               </a:rPr>
               <a:t>Option B</a:t>
             </a:r>
@@ -14339,9 +14339,9 @@
                 <a:solidFill>
                   <a:srgbClr val="FFD700"/>
                 </a:solidFill>
-                <a:latin typeface="Liberation Sans" pitchFamily="34" charset="0"/>
-                <a:ea typeface="Liberation Sans" pitchFamily="34" charset="-122"/>
-                <a:cs typeface="Liberation Sans" pitchFamily="34" charset="-120"/>
+                <a:latin typeface="Arial Black" pitchFamily="34" charset="0"/>
+                <a:ea typeface="Arial Black" pitchFamily="34" charset="-122"/>
+                <a:cs typeface="Arial Black" pitchFamily="34" charset="-120"/>
               </a:rPr>
               <a:t>1%</a:t>
             </a:r>
@@ -14356,9 +14356,9 @@
                 <a:solidFill>
                   <a:srgbClr val="FFFFFF"/>
                 </a:solidFill>
-                <a:latin typeface="Liberation Sans" pitchFamily="34" charset="0"/>
-                <a:ea typeface="Liberation Sans" pitchFamily="34" charset="-122"/>
-                <a:cs typeface="Liberation Sans" pitchFamily="34" charset="-120"/>
+                <a:latin typeface="Arial Black" pitchFamily="34" charset="0"/>
+                <a:ea typeface="Arial Black" pitchFamily="34" charset="-122"/>
+                <a:cs typeface="Arial Black" pitchFamily="34" charset="-120"/>
               </a:rPr>
               <a:t>TOP PERFORMER</a:t>
             </a:r>
@@ -14395,9 +14395,9 @@
                 <a:solidFill>
                   <a:srgbClr val="CCCCCC"/>
                 </a:solidFill>
-                <a:latin typeface="Carlito" pitchFamily="34" charset="0"/>
-                <a:ea typeface="Carlito" pitchFamily="34" charset="-122"/>
-                <a:cs typeface="Carlito" pitchFamily="34" charset="-120"/>
+                <a:latin typeface="Calibri" pitchFamily="34" charset="0"/>
+                <a:ea typeface="Calibri" pitchFamily="34" charset="-122"/>
+                <a:cs typeface="Calibri" pitchFamily="34" charset="-120"/>
               </a:rPr>
               <a:t>Stacked wordmark</a:t>
             </a:r>
@@ -14434,9 +14434,9 @@
                 <a:solidFill>
                   <a:srgbClr val="888888"/>
                 </a:solidFill>
-                <a:latin typeface="Carlito" pitchFamily="34" charset="0"/>
-                <a:ea typeface="Carlito" pitchFamily="34" charset="-122"/>
-                <a:cs typeface="Carlito" pitchFamily="34" charset="-120"/>
+                <a:latin typeface="Calibri" pitchFamily="34" charset="0"/>
+                <a:ea typeface="Calibri" pitchFamily="34" charset="-122"/>
+                <a:cs typeface="Calibri" pitchFamily="34" charset="-120"/>
               </a:rPr>
               <a:t>Bold hierarchy. Premium feel.</a:t>
             </a:r>
@@ -14500,9 +14500,9 @@
                 <a:solidFill>
                   <a:srgbClr val="888888"/>
                 </a:solidFill>
-                <a:latin typeface="Carlito" pitchFamily="34" charset="0"/>
-                <a:ea typeface="Carlito" pitchFamily="34" charset="-122"/>
-                <a:cs typeface="Carlito" pitchFamily="34" charset="-120"/>
+                <a:latin typeface="Calibri" pitchFamily="34" charset="0"/>
+                <a:ea typeface="Calibri" pitchFamily="34" charset="-122"/>
+                <a:cs typeface="Calibri" pitchFamily="34" charset="-120"/>
               </a:rPr>
               <a:t>Option C</a:t>
             </a:r>
@@ -14539,9 +14539,9 @@
                 <a:solidFill>
                   <a:srgbClr val="FFD700"/>
                 </a:solidFill>
-                <a:latin typeface="Liberation Sans" pitchFamily="34" charset="0"/>
-                <a:ea typeface="Liberation Sans" pitchFamily="34" charset="-122"/>
-                <a:cs typeface="Liberation Sans" pitchFamily="34" charset="-120"/>
+                <a:latin typeface="Arial Black" pitchFamily="34" charset="0"/>
+                <a:ea typeface="Arial Black" pitchFamily="34" charset="-122"/>
+                <a:cs typeface="Arial Black" pitchFamily="34" charset="-120"/>
               </a:rPr>
               <a:t>1%</a:t>
             </a:r>
@@ -14578,9 +14578,9 @@
                 <a:solidFill>
                   <a:srgbClr val="CCCCCC"/>
                 </a:solidFill>
-                <a:latin typeface="Carlito" pitchFamily="34" charset="0"/>
-                <a:ea typeface="Carlito" pitchFamily="34" charset="-122"/>
-                <a:cs typeface="Carlito" pitchFamily="34" charset="-120"/>
+                <a:latin typeface="Calibri" pitchFamily="34" charset="0"/>
+                <a:ea typeface="Calibri" pitchFamily="34" charset="-122"/>
+                <a:cs typeface="Calibri" pitchFamily="34" charset="-120"/>
               </a:rPr>
               <a:t>Minimalist icon</a:t>
             </a:r>
@@ -14617,9 +14617,9 @@
                 <a:solidFill>
                   <a:srgbClr val="888888"/>
                 </a:solidFill>
-                <a:latin typeface="Carlito" pitchFamily="34" charset="0"/>
-                <a:ea typeface="Carlito" pitchFamily="34" charset="-122"/>
-                <a:cs typeface="Carlito" pitchFamily="34" charset="-120"/>
+                <a:latin typeface="Calibri" pitchFamily="34" charset="0"/>
+                <a:ea typeface="Calibri" pitchFamily="34" charset="-122"/>
+                <a:cs typeface="Calibri" pitchFamily="34" charset="-120"/>
               </a:rPr>
               <a:t>App icon. Wearable. Statement.</a:t>
             </a:r>
@@ -14685,9 +14685,9 @@
                 <a:solidFill>
                   <a:srgbClr val="00D4FF"/>
                 </a:solidFill>
-                <a:latin typeface="Carlito" pitchFamily="34" charset="0"/>
-                <a:ea typeface="Carlito" pitchFamily="34" charset="-122"/>
-                <a:cs typeface="Carlito" pitchFamily="34" charset="-120"/>
+                <a:latin typeface="Calibri" pitchFamily="34" charset="0"/>
+                <a:ea typeface="Calibri" pitchFamily="34" charset="-122"/>
+                <a:cs typeface="Calibri" pitchFamily="34" charset="-120"/>
               </a:rPr>
               <a:t>AI</a:t>
             </a:r>
@@ -14699,9 +14699,9 @@
                 <a:solidFill>
                   <a:srgbClr val="888888"/>
                 </a:solidFill>
-                <a:latin typeface="Carlito" pitchFamily="34" charset="0"/>
-                <a:ea typeface="Carlito" pitchFamily="34" charset="-122"/>
-                <a:cs typeface="Carlito" pitchFamily="34" charset="-120"/>
+                <a:latin typeface="Calibri" pitchFamily="34" charset="0"/>
+                <a:ea typeface="Calibri" pitchFamily="34" charset="-122"/>
+                <a:cs typeface="Calibri" pitchFamily="34" charset="-120"/>
               </a:rPr>
               <a:t> (Artificial Intelligence)  +  </a:t>
             </a:r>
@@ -14713,9 +14713,9 @@
                 <a:solidFill>
                   <a:srgbClr val="E94560"/>
                 </a:solidFill>
-                <a:latin typeface="Carlito" pitchFamily="34" charset="0"/>
-                <a:ea typeface="Carlito" pitchFamily="34" charset="-122"/>
-                <a:cs typeface="Carlito" pitchFamily="34" charset="-120"/>
+                <a:latin typeface="Calibri" pitchFamily="34" charset="0"/>
+                <a:ea typeface="Calibri" pitchFamily="34" charset="-122"/>
+                <a:cs typeface="Calibri" pitchFamily="34" charset="-120"/>
               </a:rPr>
               <a:t>EI</a:t>
             </a:r>
@@ -14727,9 +14727,9 @@
                 <a:solidFill>
                   <a:srgbClr val="888888"/>
                 </a:solidFill>
-                <a:latin typeface="Carlito" pitchFamily="34" charset="0"/>
-                <a:ea typeface="Carlito" pitchFamily="34" charset="-122"/>
-                <a:cs typeface="Carlito" pitchFamily="34" charset="-120"/>
+                <a:latin typeface="Calibri" pitchFamily="34" charset="0"/>
+                <a:ea typeface="Calibri" pitchFamily="34" charset="-122"/>
+                <a:cs typeface="Calibri" pitchFamily="34" charset="-120"/>
               </a:rPr>
               <a:t> (Emotional Intelligence)</a:t>
             </a:r>
@@ -14837,9 +14837,9 @@
                 <a:solidFill>
                   <a:srgbClr val="00D4FF"/>
                 </a:solidFill>
-                <a:latin typeface="Carlito" pitchFamily="34" charset="0"/>
-                <a:ea typeface="Carlito" pitchFamily="34" charset="-122"/>
-                <a:cs typeface="Carlito" pitchFamily="34" charset="-120"/>
+                <a:latin typeface="Calibri" pitchFamily="34" charset="0"/>
+                <a:ea typeface="Calibri" pitchFamily="34" charset="-122"/>
+                <a:cs typeface="Calibri" pitchFamily="34" charset="-120"/>
               </a:rPr>
               <a:t>Name Power</a:t>
             </a:r>
@@ -14876,9 +14876,9 @@
                 <a:solidFill>
                   <a:srgbClr val="888888"/>
                 </a:solidFill>
-                <a:latin typeface="Carlito" pitchFamily="34" charset="0"/>
-                <a:ea typeface="Carlito" pitchFamily="34" charset="-122"/>
-                <a:cs typeface="Carlito" pitchFamily="34" charset="-120"/>
+                <a:latin typeface="Calibri" pitchFamily="34" charset="0"/>
+                <a:ea typeface="Calibri" pitchFamily="34" charset="-122"/>
+                <a:cs typeface="Calibri" pitchFamily="34" charset="-120"/>
               </a:rPr>
               <a:t>"Top Performer" is aspirational, universal, and SEO-friendly. It speaks to athletes, executives, students, and anyone who refuses to settle. The name IS the promise.</a:t>
             </a:r>
@@ -14986,9 +14986,9 @@
                 <a:solidFill>
                   <a:srgbClr val="FFD700"/>
                 </a:solidFill>
-                <a:latin typeface="Carlito" pitchFamily="34" charset="0"/>
-                <a:ea typeface="Carlito" pitchFamily="34" charset="-122"/>
-                <a:cs typeface="Carlito" pitchFamily="34" charset="-120"/>
+                <a:latin typeface="Calibri" pitchFamily="34" charset="0"/>
+                <a:ea typeface="Calibri" pitchFamily="34" charset="-122"/>
+                <a:cs typeface="Calibri" pitchFamily="34" charset="-120"/>
               </a:rPr>
               <a:t>Market Position</a:t>
             </a:r>
@@ -15025,9 +15025,9 @@
                 <a:solidFill>
                   <a:srgbClr val="888888"/>
                 </a:solidFill>
-                <a:latin typeface="Carlito" pitchFamily="34" charset="0"/>
-                <a:ea typeface="Carlito" pitchFamily="34" charset="-122"/>
-                <a:cs typeface="Carlito" pitchFamily="34" charset="-120"/>
+                <a:latin typeface="Calibri" pitchFamily="34" charset="0"/>
+                <a:ea typeface="Calibri" pitchFamily="34" charset="-122"/>
+                <a:cs typeface="Calibri" pitchFamily="34" charset="-120"/>
               </a:rPr>
               <a:t>Not a "mental health app" (stigma kills downloads). It's a PERFORMANCE tool. The 1% advantage that separates winners from everyone else. Think Nike for the mind.</a:t>
             </a:r>

</xml_diff>